<commit_message>
Esquema de calidad, pruebas y conformidad v1.0 y URL de GitHub Pages
- Plan de Pruebas: secciones de Recursos y responsabilidades y de Aprobación,
  según el modelo del docente; criterio de UAT en la aceptación del producto.
- CC03: mensaje esperado corregido según login.html; métrica responsive con 11 páginas.
- Presentación actualizada (25 diapositivas) en línea con el documento.
- URL publicada: https://diegoaaron.github.io/calidadProyecto/
</commit_message>
<xml_diff>
--- a/docs/Esquema_Calidad_Pruebas_Conformidad.pptx
+++ b/docs/Esquema_Calidad_Pruebas_Conformidad.pptx
@@ -5,7 +5,7 @@
     <p:sldMasterId id="2147483648" r:id="rId1"/>
   </p:sldMasterIdLst>
   <p:notesMasterIdLst>
-    <p:notesMasterId r:id="rId25"/>
+    <p:notesMasterId r:id="rId27"/>
   </p:notesMasterIdLst>
   <p:sldIdLst>
     <p:sldId id="256" r:id="rId2"/>
@@ -23,14 +23,16 @@
     <p:sldId id="268" r:id="rId14"/>
     <p:sldId id="269" r:id="rId15"/>
     <p:sldId id="270" r:id="rId16"/>
-    <p:sldId id="271" r:id="rId17"/>
-    <p:sldId id="272" r:id="rId18"/>
-    <p:sldId id="273" r:id="rId19"/>
-    <p:sldId id="274" r:id="rId20"/>
-    <p:sldId id="275" r:id="rId21"/>
-    <p:sldId id="276" r:id="rId22"/>
-    <p:sldId id="277" r:id="rId23"/>
-    <p:sldId id="278" r:id="rId24"/>
+    <p:sldId id="279" r:id="rId17"/>
+    <p:sldId id="271" r:id="rId18"/>
+    <p:sldId id="272" r:id="rId19"/>
+    <p:sldId id="280" r:id="rId20"/>
+    <p:sldId id="273" r:id="rId21"/>
+    <p:sldId id="274" r:id="rId22"/>
+    <p:sldId id="275" r:id="rId23"/>
+    <p:sldId id="276" r:id="rId24"/>
+    <p:sldId id="277" r:id="rId25"/>
+    <p:sldId id="278" r:id="rId26"/>
   </p:sldIdLst>
   <p:sldSz cx="9144000" cy="5143500" type="screen16x9"/>
   <p:notesSz cx="5143500" cy="9144000"/>
@@ -154,8 +156,10 @@
             <p14:sldId id="268"/>
             <p14:sldId id="269"/>
             <p14:sldId id="270"/>
+            <p14:sldId id="279"/>
             <p14:sldId id="271"/>
             <p14:sldId id="272"/>
+            <p14:sldId id="280"/>
           </p14:sldIdLst>
         </p14:section>
         <p14:section name="Conformidad" id="{4729A5D9-E5C0-64AC-639A-6694611E0BE3}">
@@ -961,7 +965,7 @@
           <a:p>
             <a:r>
               <a:rPr lang="en-US" dirty="0"/>
-              <a:t>Cinco semanas de pruebas. Las métricas de prueba indican si el plan se cumplió: casos ejecutados, casos aprobados y cobertura de requisitos.</a:t>
+              <a:t>Para empezar a probar se necesitan requisitos aprobados y el entorno listo. Para terminar, al menos el 95 % de los casos ejecutados y ningún defecto crítico abierto.</a:t>
             </a:r>
           </a:p>
         </p:txBody>
@@ -1048,7 +1052,7 @@
           <a:p>
             <a:r>
               <a:rPr lang="en-US" dirty="0"/>
-              <a:t>Los cuatro riesgos principales y lo que haremos para reducirlos.</a:t>
+              <a:t>Cinco semanas de pruebas. Las métricas de prueba indican si el plan se cumplió: casos ejecutados, casos aprobados y cobertura de requisitos.</a:t>
             </a:r>
           </a:p>
         </p:txBody>
@@ -1135,7 +1139,7 @@
           <a:p>
             <a:r>
               <a:rPr lang="en-US" dirty="0"/>
-              <a:t>Tercera parte: qué normas y leyes debe cumplir TechStore y cómo lo comprobamos.</a:t>
+              <a:t>Los cuatro riesgos principales y lo que haremos para reducirlos.</a:t>
             </a:r>
           </a:p>
         </p:txBody>
@@ -1222,7 +1226,7 @@
           <a:p>
             <a:r>
               <a:rPr lang="en-US" dirty="0"/>
-              <a:t>Seis normas o regulaciones. Para cada una se indica qué exige y cómo lo cumple la aplicación hoy. Por ejemplo, para PCI DSS el pedido guarda solo la marca y los 4 últimos dígitos de la tarjeta.</a:t>
+              <a:t>El producto se acepta solo si se cumplen los cuatro criterios a la vez.</a:t>
             </a:r>
           </a:p>
         </p:txBody>
@@ -1396,7 +1400,7 @@
           <a:p>
             <a:r>
               <a:rPr lang="en-US" dirty="0"/>
-              <a:t>Siete casos, cada uno con su requisito y su criterio de conformidad. Tres corresponden a la característica de seguridad de ISO/IEC 25010, que es el atributo del modelo del docente.</a:t>
+              <a:t>Tercera parte: qué normas y leyes debe cumplir TechStore y cómo lo comprobamos.</a:t>
             </a:r>
           </a:p>
         </p:txBody>
@@ -1483,7 +1487,7 @@
           <a:p>
             <a:r>
               <a:rPr lang="en-US" dirty="0"/>
-              <a:t>Este es el formato completo de cada caso, igual al del modelo del docente: requisito, precondiciones, entradas, pasos, resultado esperado y criterio de conformidad.</a:t>
+              <a:t>Seis normas o regulaciones. Para cada una se indica qué exige y cómo lo cumple la aplicación hoy. Por ejemplo, para PCI DSS el pedido guarda solo la marca y los 4 últimos dígitos de la tarjeta.</a:t>
             </a:r>
           </a:p>
         </p:txBody>
@@ -1570,7 +1574,7 @@
           <a:p>
             <a:r>
               <a:rPr lang="en-US" dirty="0"/>
-              <a:t>Es un avance: los casos ya están diseñados y la próxima semana se ejecutan y se registran sus resultados con evidencias.</a:t>
+              <a:t>Siete casos, cada uno con su requisito y su criterio de conformidad. Tres corresponden a la característica de seguridad de ISO/IEC 25010, que es el atributo del modelo del docente.</a:t>
             </a:r>
           </a:p>
         </p:txBody>
@@ -1657,7 +1661,7 @@
           <a:p>
             <a:r>
               <a:rPr lang="en-US" dirty="0"/>
-              <a:t>Cierro con los próximos pasos y abro espacio para preguntas.</a:t>
+              <a:t>Este es el formato completo de cada caso, igual al del modelo del docente: requisito, precondiciones, entradas, pasos, resultado esperado y criterio de conformidad.</a:t>
             </a:r>
           </a:p>
         </p:txBody>
@@ -1680,6 +1684,180 @@
             <a:fld id="{F7021451-1387-4CA6-816F-3879F97B5CBC}" type="slidenum">
               <a:rPr lang="en-US"/>
               <a:t>23</a:t>
+            </a:fld>
+            <a:endParaRPr lang="en-US"/>
+          </a:p>
+        </p:txBody>
+      </p:sp>
+    </p:spTree>
+    <p:extLst>
+      <p:ext uri="{BB962C8B-B14F-4D97-AF65-F5344CB8AC3E}">
+        <p14:creationId xmlns:p14="http://schemas.microsoft.com/office/powerpoint/2010/main" val="1024086991"/>
+      </p:ext>
+    </p:extLst>
+  </p:cSld>
+  <p:clrMapOvr>
+    <a:masterClrMapping/>
+  </p:clrMapOvr>
+</p:notes>
+</file>
+
+<file path=ppt/notesSlides/notesSlide24.xml><?xml version="1.0" encoding="utf-8"?>
+<p:notes xmlns:a="http://schemas.openxmlformats.org/drawingml/2006/main" xmlns:r="http://schemas.openxmlformats.org/officeDocument/2006/relationships" xmlns:p="http://schemas.openxmlformats.org/presentationml/2006/main">
+  <p:cSld>
+    <p:spTree>
+      <p:nvGrpSpPr>
+        <p:cNvPr id="1" name=""/>
+        <p:cNvGrpSpPr/>
+        <p:nvPr/>
+      </p:nvGrpSpPr>
+      <p:grpSpPr>
+        <a:xfrm>
+          <a:off x="0" y="0"/>
+          <a:ext cx="0" cy="0"/>
+          <a:chOff x="0" y="0"/>
+          <a:chExt cx="0" cy="0"/>
+        </a:xfrm>
+      </p:grpSpPr>
+      <p:sp>
+        <p:nvSpPr>
+          <p:cNvPr id="2" name="Slide Image Placeholder 1"/>
+          <p:cNvSpPr>
+            <a:spLocks noGrp="1" noRot="1" noChangeAspect="1"/>
+          </p:cNvSpPr>
+          <p:nvPr>
+            <p:ph type="sldImg"/>
+          </p:nvPr>
+        </p:nvSpPr>
+        <p:spPr/>
+      </p:sp>
+      <p:sp>
+        <p:nvSpPr>
+          <p:cNvPr id="3" name="Notes Placeholder 2"/>
+          <p:cNvSpPr>
+            <a:spLocks noGrp="1"/>
+          </p:cNvSpPr>
+          <p:nvPr>
+            <p:ph type="body" idx="1"/>
+          </p:nvPr>
+        </p:nvSpPr>
+        <p:spPr/>
+        <p:txBody>
+          <a:bodyPr/>
+          <a:lstStyle/>
+          <a:p>
+            <a:r>
+              <a:rPr lang="en-US" dirty="0"/>
+              <a:t>Es un avance: los casos ya están diseñados y la próxima semana se ejecutan y se registran sus resultados con evidencias.</a:t>
+            </a:r>
+          </a:p>
+        </p:txBody>
+      </p:sp>
+      <p:sp>
+        <p:nvSpPr>
+          <p:cNvPr id="4" name="Slide Number Placeholder 3"/>
+          <p:cNvSpPr>
+            <a:spLocks noGrp="1"/>
+          </p:cNvSpPr>
+          <p:nvPr>
+            <p:ph type="sldNum" sz="quarter" idx="10"/>
+          </p:nvPr>
+        </p:nvSpPr>
+        <p:spPr/>
+        <p:txBody>
+          <a:bodyPr/>
+          <a:lstStyle/>
+          <a:p>
+            <a:fld id="{F7021451-1387-4CA6-816F-3879F97B5CBC}" type="slidenum">
+              <a:rPr lang="en-US"/>
+              <a:t>24</a:t>
+            </a:fld>
+            <a:endParaRPr lang="en-US"/>
+          </a:p>
+        </p:txBody>
+      </p:sp>
+    </p:spTree>
+    <p:extLst>
+      <p:ext uri="{BB962C8B-B14F-4D97-AF65-F5344CB8AC3E}">
+        <p14:creationId xmlns:p14="http://schemas.microsoft.com/office/powerpoint/2010/main" val="1024086991"/>
+      </p:ext>
+    </p:extLst>
+  </p:cSld>
+  <p:clrMapOvr>
+    <a:masterClrMapping/>
+  </p:clrMapOvr>
+</p:notes>
+</file>
+
+<file path=ppt/notesSlides/notesSlide25.xml><?xml version="1.0" encoding="utf-8"?>
+<p:notes xmlns:a="http://schemas.openxmlformats.org/drawingml/2006/main" xmlns:r="http://schemas.openxmlformats.org/officeDocument/2006/relationships" xmlns:p="http://schemas.openxmlformats.org/presentationml/2006/main">
+  <p:cSld>
+    <p:spTree>
+      <p:nvGrpSpPr>
+        <p:cNvPr id="1" name=""/>
+        <p:cNvGrpSpPr/>
+        <p:nvPr/>
+      </p:nvGrpSpPr>
+      <p:grpSpPr>
+        <a:xfrm>
+          <a:off x="0" y="0"/>
+          <a:ext cx="0" cy="0"/>
+          <a:chOff x="0" y="0"/>
+          <a:chExt cx="0" cy="0"/>
+        </a:xfrm>
+      </p:grpSpPr>
+      <p:sp>
+        <p:nvSpPr>
+          <p:cNvPr id="2" name="Slide Image Placeholder 1"/>
+          <p:cNvSpPr>
+            <a:spLocks noGrp="1" noRot="1" noChangeAspect="1"/>
+          </p:cNvSpPr>
+          <p:nvPr>
+            <p:ph type="sldImg"/>
+          </p:nvPr>
+        </p:nvSpPr>
+        <p:spPr/>
+      </p:sp>
+      <p:sp>
+        <p:nvSpPr>
+          <p:cNvPr id="3" name="Notes Placeholder 2"/>
+          <p:cNvSpPr>
+            <a:spLocks noGrp="1"/>
+          </p:cNvSpPr>
+          <p:nvPr>
+            <p:ph type="body" idx="1"/>
+          </p:nvPr>
+        </p:nvSpPr>
+        <p:spPr/>
+        <p:txBody>
+          <a:bodyPr/>
+          <a:lstStyle/>
+          <a:p>
+            <a:r>
+              <a:rPr lang="en-US" dirty="0"/>
+              <a:t>Cierro con los próximos pasos y abro espacio para preguntas.</a:t>
+            </a:r>
+          </a:p>
+        </p:txBody>
+      </p:sp>
+      <p:sp>
+        <p:nvSpPr>
+          <p:cNvPr id="4" name="Slide Number Placeholder 3"/>
+          <p:cNvSpPr>
+            <a:spLocks noGrp="1"/>
+          </p:cNvSpPr>
+          <p:nvPr>
+            <p:ph type="sldNum" sz="quarter" idx="10"/>
+          </p:nvPr>
+        </p:nvSpPr>
+        <p:spPr/>
+        <p:txBody>
+          <a:bodyPr/>
+          <a:lstStyle/>
+          <a:p>
+            <a:fld id="{F7021451-1387-4CA6-816F-3879F97B5CBC}" type="slidenum">
+              <a:rPr lang="en-US"/>
+              <a:t>25</a:t>
             </a:fld>
             <a:endParaRPr lang="en-US"/>
           </a:p>
@@ -2952,7 +3130,7 @@
               <a:buNone/>
             </a:pPr>
             <a:r>
-              <a:rPr lang="en-US" sz="1400" b="1" kern="0" spc="200" dirty="0">
+              <a:rPr lang="en-US" sz="1400" b="1" kern="0" spc="200">
                 <a:solidFill>
                   <a:srgbClr val="FCA311"/>
                 </a:solidFill>
@@ -2960,7 +3138,7 @@
                 <a:ea typeface="Calibri" pitchFamily="34" charset="-122"/>
                 <a:cs typeface="Calibri" pitchFamily="34" charset="-120"/>
               </a:rPr>
-              <a:t>CALIDAD DE SOFTWARE · AVANCE</a:t>
+              <a:t>CALIDAD DE SOFTWARE</a:t>
             </a:r>
             <a:endParaRPr lang="en-US" sz="1400" dirty="0"/>
           </a:p>
@@ -3103,7 +3281,18 @@
                 <a:ea typeface="Calibri" pitchFamily="34" charset="-122"/>
                 <a:cs typeface="Calibri" pitchFamily="34" charset="-120"/>
               </a:rPr>
-              <a:t>Octubre de 2026 · Versión 0.1</a:t>
+              <a:t>Octubre de 2026 </a:t>
+            </a:r>
+            <a:r>
+              <a:rPr lang="en-US" sz="1400">
+                <a:solidFill>
+                  <a:srgbClr val="C9D3E3"/>
+                </a:solidFill>
+                <a:latin typeface="Calibri" pitchFamily="34" charset="0"/>
+                <a:ea typeface="Calibri" pitchFamily="34" charset="-122"/>
+                <a:cs typeface="Calibri" pitchFamily="34" charset="-120"/>
+              </a:rPr>
+              <a:t>· Versión 1.0</a:t>
             </a:r>
             <a:endParaRPr lang="en-US" sz="1400" dirty="0"/>
           </a:p>
@@ -12691,6 +12880,889 @@
 
 <file path=ppt/slides/slide16.xml><?xml version="1.0" encoding="utf-8"?>
 <p:sld xmlns:a="http://schemas.openxmlformats.org/drawingml/2006/main" xmlns:r="http://schemas.openxmlformats.org/officeDocument/2006/relationships" xmlns:p="http://schemas.openxmlformats.org/presentationml/2006/main">
+  <p:cSld name="Slide 13">
+    <p:spTree>
+      <p:nvGrpSpPr>
+        <p:cNvPr id="1" name=""/>
+        <p:cNvGrpSpPr/>
+        <p:nvPr/>
+      </p:nvGrpSpPr>
+      <p:grpSpPr>
+        <a:xfrm>
+          <a:off x="0" y="0"/>
+          <a:ext cx="0" cy="0"/>
+          <a:chOff x="0" y="0"/>
+          <a:chExt cx="0" cy="0"/>
+        </a:xfrm>
+      </p:grpSpPr>
+      <p:sp>
+        <p:nvSpPr>
+          <p:cNvPr id="2" name="Text 1"/>
+          <p:cNvSpPr>
+            <a:spLocks noGrp="1"/>
+          </p:cNvSpPr>
+          <p:nvPr>
+            <p:ph type="title" idx="101" hasCustomPrompt="1"/>
+          </p:nvPr>
+        </p:nvSpPr>
+        <p:spPr>
+          <a:xfrm>
+            <a:off x="457200" y="274320"/>
+            <a:ext cx="8229600" cy="640080"/>
+          </a:xfrm>
+          <a:prstGeom prst="rect">
+            <a:avLst/>
+          </a:prstGeom>
+          <a:noFill/>
+          <a:ln/>
+        </p:spPr>
+        <p:txBody>
+          <a:bodyPr wrap="square" lIns="0" tIns="0" rIns="0" bIns="0" rtlCol="0" anchor="ctr"/>
+          <a:lstStyle/>
+          <a:p>
+            <a:pPr marL="0" indent="0">
+              <a:buNone/>
+            </a:pPr>
+            <a:r>
+              <a:rPr lang="en-US" sz="2800" b="1">
+                <a:solidFill>
+                  <a:srgbClr val="14213D"/>
+                </a:solidFill>
+                <a:latin typeface="Calibri" pitchFamily="34" charset="0"/>
+                <a:ea typeface="Calibri" pitchFamily="34" charset="-122"/>
+                <a:cs typeface="Calibri" pitchFamily="34" charset="-120"/>
+              </a:rPr>
+              <a:t>Recursos y responsabilidades</a:t>
+            </a:r>
+            <a:endParaRPr lang="en-US" sz="2800" dirty="0"/>
+          </a:p>
+        </p:txBody>
+      </p:sp>
+      <p:sp>
+        <p:nvSpPr>
+          <p:cNvPr id="4" name="box198"/>
+          <p:cNvSpPr/>
+          <p:nvPr/>
+        </p:nvSpPr>
+        <p:spPr>
+          <a:xfrm>
+            <a:off x="457200" y="1143000"/>
+            <a:ext cx="2606040" cy="3337560"/>
+          </a:xfrm>
+          <a:prstGeom prst="roundRect">
+            <a:avLst>
+              <a:gd name="adj" fmla="val 2807"/>
+            </a:avLst>
+          </a:prstGeom>
+          <a:solidFill>
+            <a:srgbClr val="EEF2F7"/>
+          </a:solidFill>
+          <a:ln w="12700">
+            <a:solidFill>
+              <a:srgbClr val="EEF2F7"/>
+            </a:solidFill>
+            <a:prstDash val="solid"/>
+          </a:ln>
+        </p:spPr>
+        <p:txBody>
+          <a:bodyPr/>
+          <a:lstStyle/>
+          <a:p>
+            <a:endParaRPr lang="es-PE"/>
+          </a:p>
+        </p:txBody>
+      </p:sp>
+      <p:sp>
+        <p:nvSpPr>
+          <p:cNvPr id="5" name="circ199"/>
+          <p:cNvSpPr/>
+          <p:nvPr/>
+        </p:nvSpPr>
+        <p:spPr>
+          <a:xfrm>
+            <a:off x="685800" y="1325880"/>
+            <a:ext cx="502920" cy="502920"/>
+          </a:xfrm>
+          <a:prstGeom prst="ellipse">
+            <a:avLst/>
+          </a:prstGeom>
+          <a:solidFill>
+            <a:srgbClr val="14213D"/>
+          </a:solidFill>
+          <a:ln w="12700">
+            <a:solidFill>
+              <a:srgbClr val="14213D"/>
+            </a:solidFill>
+            <a:prstDash val="solid"/>
+          </a:ln>
+        </p:spPr>
+        <p:txBody>
+          <a:bodyPr/>
+          <a:lstStyle/>
+          <a:p>
+            <a:endParaRPr lang="es-PE"/>
+          </a:p>
+        </p:txBody>
+      </p:sp>
+      <p:sp>
+        <p:nvSpPr>
+          <p:cNvPr id="6" name="txt200"/>
+          <p:cNvSpPr txBox="1"/>
+          <p:nvPr/>
+        </p:nvSpPr>
+        <p:spPr>
+          <a:xfrm>
+            <a:off x="685800" y="1325880"/>
+            <a:ext cx="502920" cy="502920"/>
+          </a:xfrm>
+          <a:prstGeom prst="rect">
+            <a:avLst/>
+          </a:prstGeom>
+          <a:noFill/>
+          <a:ln/>
+        </p:spPr>
+        <p:txBody>
+          <a:bodyPr wrap="square" lIns="0" tIns="0" rIns="0" bIns="0" rtlCol="0" anchor="ctr"/>
+          <a:lstStyle/>
+          <a:p>
+            <a:pPr marL="0" indent="0" algn="ctr">
+              <a:buNone/>
+            </a:pPr>
+            <a:r>
+              <a:rPr lang="en-US" sz="1400" b="1">
+                <a:solidFill>
+                  <a:srgbClr val="FFFFFF"/>
+                </a:solidFill>
+                <a:latin typeface="Calibri" pitchFamily="34" charset="0"/>
+                <a:ea typeface="Calibri" pitchFamily="34" charset="-122"/>
+                <a:cs typeface="Calibri" pitchFamily="34" charset="-120"/>
+              </a:rPr>
+              <a:t>●</a:t>
+            </a:r>
+            <a:endParaRPr lang="en-US" sz="1400" dirty="0"/>
+          </a:p>
+        </p:txBody>
+      </p:sp>
+      <p:sp>
+        <p:nvSpPr>
+          <p:cNvPr id="7" name="txt201"/>
+          <p:cNvSpPr txBox="1"/>
+          <p:nvPr/>
+        </p:nvSpPr>
+        <p:spPr>
+          <a:xfrm>
+            <a:off x="1325880" y="1371600"/>
+            <a:ext cx="1645920" cy="411480"/>
+          </a:xfrm>
+          <a:prstGeom prst="rect">
+            <a:avLst/>
+          </a:prstGeom>
+          <a:noFill/>
+          <a:ln/>
+        </p:spPr>
+        <p:txBody>
+          <a:bodyPr wrap="square" lIns="0" tIns="0" rIns="0" bIns="0" rtlCol="0" anchor="ctr"/>
+          <a:lstStyle/>
+          <a:p>
+            <a:pPr marL="0" indent="0">
+              <a:buNone/>
+            </a:pPr>
+            <a:r>
+              <a:rPr lang="en-US" sz="2000" b="1">
+                <a:solidFill>
+                  <a:srgbClr val="14213D"/>
+                </a:solidFill>
+                <a:latin typeface="Calibri" pitchFamily="34" charset="0"/>
+                <a:ea typeface="Calibri" pitchFamily="34" charset="-122"/>
+                <a:cs typeface="Calibri" pitchFamily="34" charset="-120"/>
+              </a:rPr>
+              <a:t>Equipo</a:t>
+            </a:r>
+            <a:endParaRPr lang="en-US" sz="2000" dirty="0"/>
+          </a:p>
+        </p:txBody>
+      </p:sp>
+      <p:sp>
+        <p:nvSpPr>
+          <p:cNvPr id="8" name="txt202"/>
+          <p:cNvSpPr txBox="1"/>
+          <p:nvPr/>
+        </p:nvSpPr>
+        <p:spPr>
+          <a:xfrm>
+            <a:off x="685800" y="2057400"/>
+            <a:ext cx="2194560" cy="2286000"/>
+          </a:xfrm>
+          <a:prstGeom prst="rect">
+            <a:avLst/>
+          </a:prstGeom>
+          <a:noFill/>
+          <a:ln/>
+        </p:spPr>
+        <p:txBody>
+          <a:bodyPr wrap="square" lIns="0" tIns="0" rIns="0" bIns="0" rtlCol="0" anchor="t"/>
+          <a:lstStyle/>
+          <a:p>
+            <a:pPr marL="342900" indent="-342900">
+              <a:spcAft>
+                <a:spcPts val="800"/>
+              </a:spcAft>
+              <a:buSzPct val="100000"/>
+              <a:buChar char="•"/>
+            </a:pPr>
+            <a:r>
+              <a:rPr lang="es-MX" sz="1400">
+                <a:solidFill>
+                  <a:srgbClr val="4A5568"/>
+                </a:solidFill>
+                <a:latin typeface="Calibri" pitchFamily="34" charset="0"/>
+                <a:ea typeface="Calibri" pitchFamily="34" charset="-122"/>
+                <a:cs typeface="Calibri" pitchFamily="34" charset="-120"/>
+              </a:rPr>
+              <a:t>Líder de QA: coordina y aprueba</a:t>
+            </a:r>
+          </a:p>
+          <a:p>
+            <a:pPr marL="342900" indent="-342900">
+              <a:spcAft>
+                <a:spcPts val="800"/>
+              </a:spcAft>
+              <a:buSzPct val="100000"/>
+              <a:buChar char="•"/>
+            </a:pPr>
+            <a:r>
+              <a:rPr lang="es-MX" sz="1400">
+                <a:solidFill>
+                  <a:srgbClr val="4A5568"/>
+                </a:solidFill>
+                <a:latin typeface="Calibri" pitchFamily="34" charset="0"/>
+                <a:ea typeface="Calibri" pitchFamily="34" charset="-122"/>
+                <a:cs typeface="Calibri" pitchFamily="34" charset="-120"/>
+              </a:rPr>
+              <a:t>Desarrollador: unitarias y correcciones</a:t>
+            </a:r>
+          </a:p>
+          <a:p>
+            <a:pPr marL="342900" indent="-342900">
+              <a:spcAft>
+                <a:spcPts val="800"/>
+              </a:spcAft>
+              <a:buSzPct val="100000"/>
+              <a:buChar char="•"/>
+            </a:pPr>
+            <a:r>
+              <a:rPr lang="es-MX" sz="1400">
+                <a:solidFill>
+                  <a:srgbClr val="4A5568"/>
+                </a:solidFill>
+                <a:latin typeface="Calibri" pitchFamily="34" charset="0"/>
+                <a:ea typeface="Calibri" pitchFamily="34" charset="-122"/>
+                <a:cs typeface="Calibri" pitchFamily="34" charset="-120"/>
+              </a:rPr>
+              <a:t>Analista de QA: diseña y ejecuta casos</a:t>
+            </a:r>
+          </a:p>
+          <a:p>
+            <a:pPr marL="342900" indent="-342900">
+              <a:spcAft>
+                <a:spcPts val="800"/>
+              </a:spcAft>
+              <a:buSzPct val="100000"/>
+              <a:buChar char="•"/>
+            </a:pPr>
+            <a:r>
+              <a:rPr lang="es-MX" sz="1400">
+                <a:solidFill>
+                  <a:srgbClr val="4A5568"/>
+                </a:solidFill>
+                <a:latin typeface="Calibri" pitchFamily="34" charset="0"/>
+                <a:ea typeface="Calibri" pitchFamily="34" charset="-122"/>
+                <a:cs typeface="Calibri" pitchFamily="34" charset="-120"/>
+              </a:rPr>
+              <a:t>Usuarios clave: UAT en Maze</a:t>
+            </a:r>
+            <a:endParaRPr lang="en-US" sz="1400" dirty="0"/>
+          </a:p>
+        </p:txBody>
+      </p:sp>
+      <p:sp>
+        <p:nvSpPr>
+          <p:cNvPr id="9" name="box203"/>
+          <p:cNvSpPr/>
+          <p:nvPr/>
+        </p:nvSpPr>
+        <p:spPr>
+          <a:xfrm>
+            <a:off x="3246120" y="1143000"/>
+            <a:ext cx="2606040" cy="3337560"/>
+          </a:xfrm>
+          <a:prstGeom prst="roundRect">
+            <a:avLst>
+              <a:gd name="adj" fmla="val 2807"/>
+            </a:avLst>
+          </a:prstGeom>
+          <a:solidFill>
+            <a:srgbClr val="EEF2F7"/>
+          </a:solidFill>
+          <a:ln w="12700">
+            <a:solidFill>
+              <a:srgbClr val="EEF2F7"/>
+            </a:solidFill>
+            <a:prstDash val="solid"/>
+          </a:ln>
+        </p:spPr>
+        <p:txBody>
+          <a:bodyPr/>
+          <a:lstStyle/>
+          <a:p>
+            <a:endParaRPr lang="es-PE"/>
+          </a:p>
+        </p:txBody>
+      </p:sp>
+      <p:sp>
+        <p:nvSpPr>
+          <p:cNvPr id="10" name="circ204"/>
+          <p:cNvSpPr/>
+          <p:nvPr/>
+        </p:nvSpPr>
+        <p:spPr>
+          <a:xfrm>
+            <a:off x="3474720" y="1325880"/>
+            <a:ext cx="502920" cy="502920"/>
+          </a:xfrm>
+          <a:prstGeom prst="ellipse">
+            <a:avLst/>
+          </a:prstGeom>
+          <a:solidFill>
+            <a:srgbClr val="14213D"/>
+          </a:solidFill>
+          <a:ln w="12700">
+            <a:solidFill>
+              <a:srgbClr val="14213D"/>
+            </a:solidFill>
+            <a:prstDash val="solid"/>
+          </a:ln>
+        </p:spPr>
+        <p:txBody>
+          <a:bodyPr/>
+          <a:lstStyle/>
+          <a:p>
+            <a:endParaRPr lang="es-PE"/>
+          </a:p>
+        </p:txBody>
+      </p:sp>
+      <p:sp>
+        <p:nvSpPr>
+          <p:cNvPr id="11" name="txt205"/>
+          <p:cNvSpPr txBox="1"/>
+          <p:nvPr/>
+        </p:nvSpPr>
+        <p:spPr>
+          <a:xfrm>
+            <a:off x="3474720" y="1325880"/>
+            <a:ext cx="502920" cy="502920"/>
+          </a:xfrm>
+          <a:prstGeom prst="rect">
+            <a:avLst/>
+          </a:prstGeom>
+          <a:noFill/>
+          <a:ln/>
+        </p:spPr>
+        <p:txBody>
+          <a:bodyPr wrap="square" lIns="0" tIns="0" rIns="0" bIns="0" rtlCol="0" anchor="ctr"/>
+          <a:lstStyle/>
+          <a:p>
+            <a:pPr marL="0" indent="0" algn="ctr">
+              <a:buNone/>
+            </a:pPr>
+            <a:r>
+              <a:rPr lang="en-US" sz="1400" b="1">
+                <a:solidFill>
+                  <a:srgbClr val="FFFFFF"/>
+                </a:solidFill>
+                <a:latin typeface="Calibri" pitchFamily="34" charset="0"/>
+                <a:ea typeface="Calibri" pitchFamily="34" charset="-122"/>
+                <a:cs typeface="Calibri" pitchFamily="34" charset="-120"/>
+              </a:rPr>
+              <a:t>⚙</a:t>
+            </a:r>
+            <a:endParaRPr lang="en-US" sz="1400" dirty="0"/>
+          </a:p>
+        </p:txBody>
+      </p:sp>
+      <p:sp>
+        <p:nvSpPr>
+          <p:cNvPr id="12" name="txt206"/>
+          <p:cNvSpPr txBox="1"/>
+          <p:nvPr/>
+        </p:nvSpPr>
+        <p:spPr>
+          <a:xfrm>
+            <a:off x="4114800" y="1371600"/>
+            <a:ext cx="1645920" cy="411480"/>
+          </a:xfrm>
+          <a:prstGeom prst="rect">
+            <a:avLst/>
+          </a:prstGeom>
+          <a:noFill/>
+          <a:ln/>
+        </p:spPr>
+        <p:txBody>
+          <a:bodyPr wrap="square" lIns="0" tIns="0" rIns="0" bIns="0" rtlCol="0" anchor="ctr"/>
+          <a:lstStyle/>
+          <a:p>
+            <a:pPr marL="0" indent="0">
+              <a:buNone/>
+            </a:pPr>
+            <a:r>
+              <a:rPr lang="en-US" sz="2000" b="1">
+                <a:solidFill>
+                  <a:srgbClr val="14213D"/>
+                </a:solidFill>
+                <a:latin typeface="Calibri" pitchFamily="34" charset="0"/>
+                <a:ea typeface="Calibri" pitchFamily="34" charset="-122"/>
+                <a:cs typeface="Calibri" pitchFamily="34" charset="-120"/>
+              </a:rPr>
+              <a:t>Entorno</a:t>
+            </a:r>
+            <a:endParaRPr lang="en-US" sz="2000" dirty="0"/>
+          </a:p>
+        </p:txBody>
+      </p:sp>
+      <p:sp>
+        <p:nvSpPr>
+          <p:cNvPr id="13" name="txt207"/>
+          <p:cNvSpPr txBox="1"/>
+          <p:nvPr/>
+        </p:nvSpPr>
+        <p:spPr>
+          <a:xfrm>
+            <a:off x="3474720" y="2057400"/>
+            <a:ext cx="2194560" cy="2286000"/>
+          </a:xfrm>
+          <a:prstGeom prst="rect">
+            <a:avLst/>
+          </a:prstGeom>
+          <a:noFill/>
+          <a:ln/>
+        </p:spPr>
+        <p:txBody>
+          <a:bodyPr wrap="square" lIns="0" tIns="0" rIns="0" bIns="0" rtlCol="0" anchor="t"/>
+          <a:lstStyle/>
+          <a:p>
+            <a:pPr marL="342900" indent="-342900">
+              <a:spcAft>
+                <a:spcPts val="800"/>
+              </a:spcAft>
+              <a:buSzPct val="100000"/>
+              <a:buChar char="•"/>
+            </a:pPr>
+            <a:r>
+              <a:rPr lang="en-US" sz="1400">
+                <a:solidFill>
+                  <a:srgbClr val="4A5568"/>
+                </a:solidFill>
+                <a:latin typeface="Calibri" pitchFamily="34" charset="0"/>
+                <a:ea typeface="Calibri" pitchFamily="34" charset="-122"/>
+                <a:cs typeface="Calibri" pitchFamily="34" charset="-120"/>
+              </a:rPr>
+              <a:t>GitHub Pages</a:t>
+            </a:r>
+          </a:p>
+          <a:p>
+            <a:pPr marL="342900" indent="-342900">
+              <a:spcAft>
+                <a:spcPts val="800"/>
+              </a:spcAft>
+              <a:buSzPct val="100000"/>
+              <a:buChar char="•"/>
+            </a:pPr>
+            <a:r>
+              <a:rPr lang="en-US" sz="1400">
+                <a:solidFill>
+                  <a:srgbClr val="4A5568"/>
+                </a:solidFill>
+                <a:latin typeface="Calibri" pitchFamily="34" charset="0"/>
+                <a:ea typeface="Calibri" pitchFamily="34" charset="-122"/>
+                <a:cs typeface="Calibri" pitchFamily="34" charset="-120"/>
+              </a:rPr>
+              <a:t>Chrome, Edge y Firefox</a:t>
+            </a:r>
+          </a:p>
+          <a:p>
+            <a:pPr marL="342900" indent="-342900">
+              <a:spcAft>
+                <a:spcPts val="800"/>
+              </a:spcAft>
+              <a:buSzPct val="100000"/>
+              <a:buChar char="•"/>
+            </a:pPr>
+            <a:r>
+              <a:rPr lang="en-US" sz="1400">
+                <a:solidFill>
+                  <a:srgbClr val="4A5568"/>
+                </a:solidFill>
+                <a:latin typeface="Calibri" pitchFamily="34" charset="0"/>
+                <a:ea typeface="Calibri" pitchFamily="34" charset="-122"/>
+                <a:cs typeface="Calibri" pitchFamily="34" charset="-120"/>
+              </a:rPr>
+              <a:t>Vista móvil de 375 px</a:t>
+            </a:r>
+          </a:p>
+          <a:p>
+            <a:pPr marL="342900" indent="-342900">
+              <a:spcAft>
+                <a:spcPts val="800"/>
+              </a:spcAft>
+              <a:buSzPct val="100000"/>
+              <a:buChar char="•"/>
+            </a:pPr>
+            <a:r>
+              <a:rPr lang="en-US" sz="1400">
+                <a:solidFill>
+                  <a:srgbClr val="4A5568"/>
+                </a:solidFill>
+                <a:latin typeface="Calibri" pitchFamily="34" charset="0"/>
+                <a:ea typeface="Calibri" pitchFamily="34" charset="-122"/>
+                <a:cs typeface="Calibri" pitchFamily="34" charset="-120"/>
+              </a:rPr>
+              <a:t>tests.html, DevTools, Lighthouse, Maze, GitHub Issues</a:t>
+            </a:r>
+            <a:endParaRPr lang="en-US" sz="1400" dirty="0"/>
+          </a:p>
+        </p:txBody>
+      </p:sp>
+      <p:sp>
+        <p:nvSpPr>
+          <p:cNvPr id="14" name="box208"/>
+          <p:cNvSpPr/>
+          <p:nvPr/>
+        </p:nvSpPr>
+        <p:spPr>
+          <a:xfrm>
+            <a:off x="6035040" y="1143000"/>
+            <a:ext cx="2606040" cy="3337560"/>
+          </a:xfrm>
+          <a:prstGeom prst="roundRect">
+            <a:avLst>
+              <a:gd name="adj" fmla="val 2807"/>
+            </a:avLst>
+          </a:prstGeom>
+          <a:solidFill>
+            <a:srgbClr val="EEF2F7"/>
+          </a:solidFill>
+          <a:ln w="12700">
+            <a:solidFill>
+              <a:srgbClr val="EEF2F7"/>
+            </a:solidFill>
+            <a:prstDash val="solid"/>
+          </a:ln>
+        </p:spPr>
+        <p:txBody>
+          <a:bodyPr/>
+          <a:lstStyle/>
+          <a:p>
+            <a:endParaRPr lang="es-PE"/>
+          </a:p>
+        </p:txBody>
+      </p:sp>
+      <p:sp>
+        <p:nvSpPr>
+          <p:cNvPr id="15" name="circ209"/>
+          <p:cNvSpPr/>
+          <p:nvPr/>
+        </p:nvSpPr>
+        <p:spPr>
+          <a:xfrm>
+            <a:off x="6263640" y="1325880"/>
+            <a:ext cx="502920" cy="502920"/>
+          </a:xfrm>
+          <a:prstGeom prst="ellipse">
+            <a:avLst/>
+          </a:prstGeom>
+          <a:solidFill>
+            <a:srgbClr val="14213D"/>
+          </a:solidFill>
+          <a:ln w="12700">
+            <a:solidFill>
+              <a:srgbClr val="14213D"/>
+            </a:solidFill>
+            <a:prstDash val="solid"/>
+          </a:ln>
+        </p:spPr>
+        <p:txBody>
+          <a:bodyPr/>
+          <a:lstStyle/>
+          <a:p>
+            <a:endParaRPr lang="es-PE"/>
+          </a:p>
+        </p:txBody>
+      </p:sp>
+      <p:sp>
+        <p:nvSpPr>
+          <p:cNvPr id="16" name="txt210"/>
+          <p:cNvSpPr txBox="1"/>
+          <p:nvPr/>
+        </p:nvSpPr>
+        <p:spPr>
+          <a:xfrm>
+            <a:off x="6263640" y="1325880"/>
+            <a:ext cx="502920" cy="502920"/>
+          </a:xfrm>
+          <a:prstGeom prst="rect">
+            <a:avLst/>
+          </a:prstGeom>
+          <a:noFill/>
+          <a:ln/>
+        </p:spPr>
+        <p:txBody>
+          <a:bodyPr wrap="square" lIns="0" tIns="0" rIns="0" bIns="0" rtlCol="0" anchor="ctr"/>
+          <a:lstStyle/>
+          <a:p>
+            <a:pPr marL="0" indent="0" algn="ctr">
+              <a:buNone/>
+            </a:pPr>
+            <a:r>
+              <a:rPr lang="en-US" sz="1400" b="1">
+                <a:solidFill>
+                  <a:srgbClr val="FFFFFF"/>
+                </a:solidFill>
+                <a:latin typeface="Calibri" pitchFamily="34" charset="0"/>
+                <a:ea typeface="Calibri" pitchFamily="34" charset="-122"/>
+                <a:cs typeface="Calibri" pitchFamily="34" charset="-120"/>
+              </a:rPr>
+              <a:t>▣</a:t>
+            </a:r>
+            <a:endParaRPr lang="en-US" sz="1400" dirty="0"/>
+          </a:p>
+        </p:txBody>
+      </p:sp>
+      <p:sp>
+        <p:nvSpPr>
+          <p:cNvPr id="17" name="txt211"/>
+          <p:cNvSpPr txBox="1"/>
+          <p:nvPr/>
+        </p:nvSpPr>
+        <p:spPr>
+          <a:xfrm>
+            <a:off x="6903720" y="1371600"/>
+            <a:ext cx="1645920" cy="411480"/>
+          </a:xfrm>
+          <a:prstGeom prst="rect">
+            <a:avLst/>
+          </a:prstGeom>
+          <a:noFill/>
+          <a:ln/>
+        </p:spPr>
+        <p:txBody>
+          <a:bodyPr wrap="square" lIns="0" tIns="0" rIns="0" bIns="0" rtlCol="0" anchor="ctr"/>
+          <a:lstStyle/>
+          <a:p>
+            <a:pPr marL="0" indent="0">
+              <a:buNone/>
+            </a:pPr>
+            <a:r>
+              <a:rPr lang="en-US" sz="2000" b="1">
+                <a:solidFill>
+                  <a:srgbClr val="14213D"/>
+                </a:solidFill>
+                <a:latin typeface="Calibri" pitchFamily="34" charset="0"/>
+                <a:ea typeface="Calibri" pitchFamily="34" charset="-122"/>
+                <a:cs typeface="Calibri" pitchFamily="34" charset="-120"/>
+              </a:rPr>
+              <a:t>Datos demo</a:t>
+            </a:r>
+            <a:endParaRPr lang="en-US" sz="2000" dirty="0"/>
+          </a:p>
+        </p:txBody>
+      </p:sp>
+      <p:sp>
+        <p:nvSpPr>
+          <p:cNvPr id="18" name="txt212"/>
+          <p:cNvSpPr txBox="1"/>
+          <p:nvPr/>
+        </p:nvSpPr>
+        <p:spPr>
+          <a:xfrm>
+            <a:off x="6263640" y="2057400"/>
+            <a:ext cx="2194560" cy="2286000"/>
+          </a:xfrm>
+          <a:prstGeom prst="rect">
+            <a:avLst/>
+          </a:prstGeom>
+          <a:noFill/>
+          <a:ln/>
+        </p:spPr>
+        <p:txBody>
+          <a:bodyPr wrap="square" lIns="0" tIns="0" rIns="0" bIns="0" rtlCol="0" anchor="t"/>
+          <a:lstStyle/>
+          <a:p>
+            <a:pPr marL="342900" indent="-342900">
+              <a:spcAft>
+                <a:spcPts val="800"/>
+              </a:spcAft>
+              <a:buSzPct val="100000"/>
+              <a:buChar char="•"/>
+            </a:pPr>
+            <a:r>
+              <a:rPr lang="es-MX" sz="1400">
+                <a:solidFill>
+                  <a:srgbClr val="4A5568"/>
+                </a:solidFill>
+                <a:latin typeface="Calibri" pitchFamily="34" charset="0"/>
+                <a:ea typeface="Calibri" pitchFamily="34" charset="-122"/>
+                <a:cs typeface="Calibri" pitchFamily="34" charset="-120"/>
+              </a:rPr>
+              <a:t>Usuario: demo@techstore.pe</a:t>
+            </a:r>
+          </a:p>
+          <a:p>
+            <a:pPr marL="342900" indent="-342900">
+              <a:spcAft>
+                <a:spcPts val="800"/>
+              </a:spcAft>
+              <a:buSzPct val="100000"/>
+              <a:buChar char="•"/>
+            </a:pPr>
+            <a:r>
+              <a:rPr lang="es-MX" sz="1400">
+                <a:solidFill>
+                  <a:srgbClr val="4A5568"/>
+                </a:solidFill>
+                <a:latin typeface="Calibri" pitchFamily="34" charset="0"/>
+                <a:ea typeface="Calibri" pitchFamily="34" charset="-122"/>
+                <a:cs typeface="Calibri" pitchFamily="34" charset="-120"/>
+              </a:rPr>
+              <a:t>Clave: Demo@1234</a:t>
+            </a:r>
+          </a:p>
+          <a:p>
+            <a:pPr marL="342900" indent="-342900">
+              <a:spcAft>
+                <a:spcPts val="800"/>
+              </a:spcAft>
+              <a:buSzPct val="100000"/>
+              <a:buChar char="•"/>
+            </a:pPr>
+            <a:r>
+              <a:rPr lang="es-MX" sz="1400">
+                <a:solidFill>
+                  <a:srgbClr val="4A5568"/>
+                </a:solidFill>
+                <a:latin typeface="Calibri" pitchFamily="34" charset="0"/>
+                <a:ea typeface="Calibri" pitchFamily="34" charset="-122"/>
+                <a:cs typeface="Calibri" pitchFamily="34" charset="-120"/>
+              </a:rPr>
+              <a:t>Tarjeta:</a:t>
+            </a:r>
+            <a:br>
+              <a:rPr lang="es-MX" sz="1400">
+                <a:solidFill>
+                  <a:srgbClr val="4A5568"/>
+                </a:solidFill>
+                <a:latin typeface="Calibri" pitchFamily="34" charset="0"/>
+                <a:ea typeface="Calibri" pitchFamily="34" charset="-122"/>
+                <a:cs typeface="Calibri" pitchFamily="34" charset="-120"/>
+              </a:rPr>
+            </a:br>
+            <a:r>
+              <a:rPr lang="es-MX" sz="1400">
+                <a:solidFill>
+                  <a:srgbClr val="4A5568"/>
+                </a:solidFill>
+                <a:latin typeface="Calibri" pitchFamily="34" charset="0"/>
+                <a:ea typeface="Calibri" pitchFamily="34" charset="-122"/>
+                <a:cs typeface="Calibri" pitchFamily="34" charset="-120"/>
+              </a:rPr>
+              <a:t>4111 1111 1111 1111</a:t>
+            </a:r>
+          </a:p>
+          <a:p>
+            <a:pPr marL="342900" indent="-342900">
+              <a:spcAft>
+                <a:spcPts val="800"/>
+              </a:spcAft>
+              <a:buSzPct val="100000"/>
+              <a:buChar char="•"/>
+            </a:pPr>
+            <a:r>
+              <a:rPr lang="es-MX" sz="1400">
+                <a:solidFill>
+                  <a:srgbClr val="4A5568"/>
+                </a:solidFill>
+                <a:latin typeface="Calibri" pitchFamily="34" charset="0"/>
+                <a:ea typeface="Calibri" pitchFamily="34" charset="-122"/>
+                <a:cs typeface="Calibri" pitchFamily="34" charset="-120"/>
+              </a:rPr>
+              <a:t>Restablecer datos de demo antes de cada ciclo</a:t>
+            </a:r>
+            <a:endParaRPr lang="en-US" sz="1400" dirty="0"/>
+          </a:p>
+        </p:txBody>
+      </p:sp>
+      <p:sp>
+        <p:nvSpPr>
+          <p:cNvPr id="25" name="Slide Number Placeholder 0"/>
+          <p:cNvSpPr>
+            <a:spLocks noGrp="1"/>
+          </p:cNvSpPr>
+          <p:nvPr>
+            <p:ph type="sldNum" sz="quarter" idx="4294967295"/>
+          </p:nvPr>
+        </p:nvSpPr>
+        <p:spPr>
+          <a:xfrm>
+            <a:off x="8229600" y="4754880"/>
+            <a:ext cx="457200" cy="274320"/>
+          </a:xfrm>
+          <a:prstGeom prst="rect">
+            <a:avLst/>
+          </a:prstGeom>
+          <a:extLst>
+            <a:ext uri="{C572A759-6A51-4108-AA02-DFA0A04FC94B}">
+              <ma14:wrappingTextBoxFlag xmlns="" xmlns:ma14="http://schemas.microsoft.com/office/mac/drawingml/2011/main" val="0"/>
+            </a:ext>
+          </a:extLst>
+        </p:spPr>
+        <p:txBody>
+          <a:bodyPr/>
+          <a:lstStyle>
+            <a:lvl1pPr>
+              <a:defRPr sz="1000">
+                <a:solidFill>
+                  <a:srgbClr val="8A94A6"/>
+                </a:solidFill>
+                <a:latin typeface="Calibri"/>
+                <a:ea typeface="Calibri"/>
+                <a:cs typeface="Calibri"/>
+              </a:defRPr>
+            </a:lvl1pPr>
+          </a:lstStyle>
+          <a:p>
+            <a:pPr algn="r"/>
+            <a:fld id="{F7021451-1387-4CA6-816F-3879F97B5CBC}" type="slidenum">
+              <a:rPr lang="en-US" b="0"/>
+              <a:t>16</a:t>
+            </a:fld>
+            <a:endParaRPr lang="en-US"/>
+          </a:p>
+        </p:txBody>
+      </p:sp>
+    </p:spTree>
+    <p:extLst>
+      <p:ext uri="{BB962C8B-B14F-4D97-AF65-F5344CB8AC3E}">
+        <p14:creationId xmlns:p14="http://schemas.microsoft.com/office/powerpoint/2010/main" val="2346468266"/>
+      </p:ext>
+    </p:extLst>
+  </p:cSld>
+  <p:clrMapOvr>
+    <a:masterClrMapping/>
+  </p:clrMapOvr>
+</p:sld>
+</file>
+
+<file path=ppt/slides/slide17.xml><?xml version="1.0" encoding="utf-8"?>
+<p:sld xmlns:a="http://schemas.openxmlformats.org/drawingml/2006/main" xmlns:r="http://schemas.openxmlformats.org/officeDocument/2006/relationships" xmlns:p="http://schemas.openxmlformats.org/presentationml/2006/main">
   <p:cSld name="Slide 16">
     <p:spTree>
       <p:nvGrpSpPr>
@@ -14014,7 +15086,7 @@
             <a:pPr algn="r"/>
             <a:fld id="{F7021451-1387-4CA6-816F-3879F97B5CBC}" type="slidenum">
               <a:rPr lang="en-US" b="0"/>
-              <a:t>16</a:t>
+              <a:t>17</a:t>
             </a:fld>
             <a:endParaRPr lang="en-US"/>
           </a:p>
@@ -14028,7 +15100,7 @@
 </p:sld>
 </file>
 
-<file path=ppt/slides/slide17.xml><?xml version="1.0" encoding="utf-8"?>
+<file path=ppt/slides/slide18.xml><?xml version="1.0" encoding="utf-8"?>
 <p:sld xmlns:a="http://schemas.openxmlformats.org/drawingml/2006/main" xmlns:r="http://schemas.openxmlformats.org/officeDocument/2006/relationships" xmlns:p="http://schemas.openxmlformats.org/presentationml/2006/main">
   <p:cSld name="Slide 17">
     <p:spTree>
@@ -14842,7 +15914,7 @@
             <a:pPr algn="r"/>
             <a:fld id="{F7021451-1387-4CA6-816F-3879F97B5CBC}" type="slidenum">
               <a:rPr lang="en-US" b="0"/>
-              <a:t>17</a:t>
+              <a:t>18</a:t>
             </a:fld>
             <a:endParaRPr lang="en-US"/>
           </a:p>
@@ -14856,7 +15928,1325 @@
 </p:sld>
 </file>
 
-<file path=ppt/slides/slide18.xml><?xml version="1.0" encoding="utf-8"?>
+<file path=ppt/slides/slide19.xml><?xml version="1.0" encoding="utf-8"?>
+<p:sld xmlns:a="http://schemas.openxmlformats.org/drawingml/2006/main" xmlns:r="http://schemas.openxmlformats.org/officeDocument/2006/relationships" xmlns:p="http://schemas.openxmlformats.org/presentationml/2006/main">
+  <p:cSld name="Slide 9">
+    <p:spTree>
+      <p:nvGrpSpPr>
+        <p:cNvPr id="1" name=""/>
+        <p:cNvGrpSpPr/>
+        <p:nvPr/>
+      </p:nvGrpSpPr>
+      <p:grpSpPr>
+        <a:xfrm>
+          <a:off x="0" y="0"/>
+          <a:ext cx="0" cy="0"/>
+          <a:chOff x="0" y="0"/>
+          <a:chExt cx="0" cy="0"/>
+        </a:xfrm>
+      </p:grpSpPr>
+      <p:sp>
+        <p:nvSpPr>
+          <p:cNvPr id="2" name="Text 1"/>
+          <p:cNvSpPr>
+            <a:spLocks noGrp="1"/>
+          </p:cNvSpPr>
+          <p:nvPr>
+            <p:ph type="title" idx="101" hasCustomPrompt="1"/>
+          </p:nvPr>
+        </p:nvSpPr>
+        <p:spPr>
+          <a:xfrm>
+            <a:off x="457200" y="274320"/>
+            <a:ext cx="8229600" cy="640080"/>
+          </a:xfrm>
+          <a:prstGeom prst="rect">
+            <a:avLst/>
+          </a:prstGeom>
+          <a:noFill/>
+          <a:ln/>
+        </p:spPr>
+        <p:txBody>
+          <a:bodyPr wrap="square" lIns="0" tIns="0" rIns="0" bIns="0" rtlCol="0" anchor="ctr"/>
+          <a:lstStyle/>
+          <a:p>
+            <a:pPr marL="0" indent="0">
+              <a:buNone/>
+            </a:pPr>
+            <a:r>
+              <a:rPr lang="en-US" sz="2800" b="1">
+                <a:solidFill>
+                  <a:srgbClr val="14213D"/>
+                </a:solidFill>
+                <a:latin typeface="Calibri" pitchFamily="34" charset="0"/>
+                <a:ea typeface="Calibri" pitchFamily="34" charset="-122"/>
+                <a:cs typeface="Calibri" pitchFamily="34" charset="-120"/>
+              </a:rPr>
+              <a:t>Aprobación del software</a:t>
+            </a:r>
+            <a:endParaRPr lang="en-US" sz="2800" dirty="0"/>
+          </a:p>
+        </p:txBody>
+      </p:sp>
+      <p:sp>
+        <p:nvSpPr>
+          <p:cNvPr id="4" name="box151"/>
+          <p:cNvSpPr/>
+          <p:nvPr/>
+        </p:nvSpPr>
+        <p:spPr>
+          <a:xfrm>
+            <a:off x="457200" y="1463040"/>
+            <a:ext cx="1917700" cy="2377440"/>
+          </a:xfrm>
+          <a:prstGeom prst="roundRect">
+            <a:avLst>
+              <a:gd name="adj" fmla="val 3810"/>
+            </a:avLst>
+          </a:prstGeom>
+          <a:solidFill>
+            <a:srgbClr val="14213D"/>
+          </a:solidFill>
+          <a:ln w="12700">
+            <a:solidFill>
+              <a:srgbClr val="14213D"/>
+            </a:solidFill>
+            <a:prstDash val="solid"/>
+          </a:ln>
+        </p:spPr>
+        <p:txBody>
+          <a:bodyPr/>
+          <a:lstStyle/>
+          <a:p>
+            <a:endParaRPr lang="es-PE"/>
+          </a:p>
+        </p:txBody>
+      </p:sp>
+      <p:sp>
+        <p:nvSpPr>
+          <p:cNvPr id="5" name="txt152"/>
+          <p:cNvSpPr txBox="1"/>
+          <p:nvPr/>
+        </p:nvSpPr>
+        <p:spPr>
+          <a:xfrm>
+            <a:off x="596900" y="1737360"/>
+            <a:ext cx="1638300" cy="822960"/>
+          </a:xfrm>
+          <a:prstGeom prst="rect">
+            <a:avLst/>
+          </a:prstGeom>
+          <a:noFill/>
+          <a:ln/>
+        </p:spPr>
+        <p:txBody>
+          <a:bodyPr wrap="square" lIns="0" tIns="0" rIns="0" bIns="0" rtlCol="0" anchor="ctr"/>
+          <a:lstStyle/>
+          <a:p>
+            <a:pPr marL="0" indent="0" algn="ctr">
+              <a:buNone/>
+            </a:pPr>
+            <a:r>
+              <a:rPr lang="en-US" sz="3600" b="1">
+                <a:solidFill>
+                  <a:srgbClr val="FCA311"/>
+                </a:solidFill>
+                <a:latin typeface="Calibri" pitchFamily="34" charset="0"/>
+                <a:ea typeface="Calibri" pitchFamily="34" charset="-122"/>
+                <a:cs typeface="Calibri" pitchFamily="34" charset="-120"/>
+              </a:rPr>
+              <a:t>100 %</a:t>
+            </a:r>
+            <a:endParaRPr lang="en-US" sz="3600" dirty="0"/>
+          </a:p>
+        </p:txBody>
+      </p:sp>
+      <p:sp>
+        <p:nvSpPr>
+          <p:cNvPr id="6" name="txt153"/>
+          <p:cNvSpPr txBox="1"/>
+          <p:nvPr/>
+        </p:nvSpPr>
+        <p:spPr>
+          <a:xfrm>
+            <a:off x="596900" y="2697480"/>
+            <a:ext cx="1638300" cy="914400"/>
+          </a:xfrm>
+          <a:prstGeom prst="rect">
+            <a:avLst/>
+          </a:prstGeom>
+          <a:noFill/>
+          <a:ln/>
+        </p:spPr>
+        <p:txBody>
+          <a:bodyPr wrap="square" lIns="0" tIns="0" rIns="0" bIns="0" rtlCol="0" anchor="t"/>
+          <a:lstStyle/>
+          <a:p>
+            <a:pPr marL="0" indent="0" algn="ctr">
+              <a:buNone/>
+            </a:pPr>
+            <a:r>
+              <a:rPr lang="es-MX" sz="1400">
+                <a:solidFill>
+                  <a:srgbClr val="FFFFFF"/>
+                </a:solidFill>
+                <a:latin typeface="Calibri" pitchFamily="34" charset="0"/>
+                <a:ea typeface="Calibri" pitchFamily="34" charset="-122"/>
+                <a:cs typeface="Calibri" pitchFamily="34" charset="-120"/>
+              </a:rPr>
+              <a:t>de los criterios de salida cumplidos</a:t>
+            </a:r>
+            <a:endParaRPr lang="en-US" sz="1400" dirty="0"/>
+          </a:p>
+        </p:txBody>
+      </p:sp>
+      <p:sp>
+        <p:nvSpPr>
+          <p:cNvPr id="7" name="box154"/>
+          <p:cNvSpPr/>
+          <p:nvPr/>
+        </p:nvSpPr>
+        <p:spPr>
+          <a:xfrm>
+            <a:off x="2560320" y="1463040"/>
+            <a:ext cx="1917700" cy="2377440"/>
+          </a:xfrm>
+          <a:prstGeom prst="roundRect">
+            <a:avLst>
+              <a:gd name="adj" fmla="val 3810"/>
+            </a:avLst>
+          </a:prstGeom>
+          <a:solidFill>
+            <a:srgbClr val="EEF2F7"/>
+          </a:solidFill>
+          <a:ln w="12700">
+            <a:solidFill>
+              <a:srgbClr val="EEF2F7"/>
+            </a:solidFill>
+            <a:prstDash val="solid"/>
+          </a:ln>
+        </p:spPr>
+        <p:txBody>
+          <a:bodyPr/>
+          <a:lstStyle/>
+          <a:p>
+            <a:endParaRPr lang="es-PE"/>
+          </a:p>
+        </p:txBody>
+      </p:sp>
+      <p:sp>
+        <p:nvSpPr>
+          <p:cNvPr id="8" name="txt155"/>
+          <p:cNvSpPr txBox="1"/>
+          <p:nvPr/>
+        </p:nvSpPr>
+        <p:spPr>
+          <a:xfrm>
+            <a:off x="2700020" y="1737360"/>
+            <a:ext cx="1638300" cy="822960"/>
+          </a:xfrm>
+          <a:prstGeom prst="rect">
+            <a:avLst/>
+          </a:prstGeom>
+          <a:noFill/>
+          <a:ln/>
+        </p:spPr>
+        <p:txBody>
+          <a:bodyPr wrap="square" lIns="0" tIns="0" rIns="0" bIns="0" rtlCol="0" anchor="ctr"/>
+          <a:lstStyle/>
+          <a:p>
+            <a:pPr marL="0" indent="0" algn="ctr">
+              <a:buNone/>
+            </a:pPr>
+            <a:r>
+              <a:rPr lang="en-US" sz="3600" b="1">
+                <a:solidFill>
+                  <a:srgbClr val="14213D"/>
+                </a:solidFill>
+                <a:latin typeface="Calibri" pitchFamily="34" charset="0"/>
+                <a:ea typeface="Calibri" pitchFamily="34" charset="-122"/>
+                <a:cs typeface="Calibri" pitchFamily="34" charset="-120"/>
+              </a:rPr>
+              <a:t>0</a:t>
+            </a:r>
+            <a:endParaRPr lang="en-US" sz="3600" dirty="0"/>
+          </a:p>
+        </p:txBody>
+      </p:sp>
+      <p:sp>
+        <p:nvSpPr>
+          <p:cNvPr id="9" name="txt156"/>
+          <p:cNvSpPr txBox="1"/>
+          <p:nvPr/>
+        </p:nvSpPr>
+        <p:spPr>
+          <a:xfrm>
+            <a:off x="2700020" y="2697480"/>
+            <a:ext cx="1638300" cy="914400"/>
+          </a:xfrm>
+          <a:prstGeom prst="rect">
+            <a:avLst/>
+          </a:prstGeom>
+          <a:noFill/>
+          <a:ln/>
+        </p:spPr>
+        <p:txBody>
+          <a:bodyPr wrap="square" lIns="0" tIns="0" rIns="0" bIns="0" rtlCol="0" anchor="t"/>
+          <a:lstStyle/>
+          <a:p>
+            <a:pPr marL="0" indent="0" algn="ctr">
+              <a:buNone/>
+            </a:pPr>
+            <a:r>
+              <a:rPr lang="en-US" sz="1400">
+                <a:solidFill>
+                  <a:srgbClr val="4A5568"/>
+                </a:solidFill>
+                <a:latin typeface="Calibri" pitchFamily="34" charset="0"/>
+                <a:ea typeface="Calibri" pitchFamily="34" charset="-122"/>
+                <a:cs typeface="Calibri" pitchFamily="34" charset="-120"/>
+              </a:rPr>
+              <a:t>defectos críticos o altos sin corregir</a:t>
+            </a:r>
+            <a:endParaRPr lang="en-US" sz="1400" dirty="0"/>
+          </a:p>
+        </p:txBody>
+      </p:sp>
+      <p:sp>
+        <p:nvSpPr>
+          <p:cNvPr id="10" name="box157"/>
+          <p:cNvSpPr/>
+          <p:nvPr/>
+        </p:nvSpPr>
+        <p:spPr>
+          <a:xfrm>
+            <a:off x="4663440" y="1463040"/>
+            <a:ext cx="1917700" cy="2377440"/>
+          </a:xfrm>
+          <a:prstGeom prst="roundRect">
+            <a:avLst>
+              <a:gd name="adj" fmla="val 3810"/>
+            </a:avLst>
+          </a:prstGeom>
+          <a:solidFill>
+            <a:srgbClr val="EEF2F7"/>
+          </a:solidFill>
+          <a:ln w="12700">
+            <a:solidFill>
+              <a:srgbClr val="EEF2F7"/>
+            </a:solidFill>
+            <a:prstDash val="solid"/>
+          </a:ln>
+        </p:spPr>
+        <p:txBody>
+          <a:bodyPr/>
+          <a:lstStyle/>
+          <a:p>
+            <a:endParaRPr lang="es-PE"/>
+          </a:p>
+        </p:txBody>
+      </p:sp>
+      <p:sp>
+        <p:nvSpPr>
+          <p:cNvPr id="11" name="txt158"/>
+          <p:cNvSpPr txBox="1"/>
+          <p:nvPr/>
+        </p:nvSpPr>
+        <p:spPr>
+          <a:xfrm>
+            <a:off x="4803140" y="1737360"/>
+            <a:ext cx="1638300" cy="822960"/>
+          </a:xfrm>
+          <a:prstGeom prst="rect">
+            <a:avLst/>
+          </a:prstGeom>
+          <a:noFill/>
+          <a:ln/>
+        </p:spPr>
+        <p:txBody>
+          <a:bodyPr wrap="square" lIns="0" tIns="0" rIns="0" bIns="0" rtlCol="0" anchor="ctr"/>
+          <a:lstStyle/>
+          <a:p>
+            <a:pPr marL="0" indent="0" algn="ctr">
+              <a:buNone/>
+            </a:pPr>
+            <a:r>
+              <a:rPr lang="en-US" sz="3600" b="1">
+                <a:solidFill>
+                  <a:srgbClr val="14213D"/>
+                </a:solidFill>
+                <a:latin typeface="Calibri" pitchFamily="34" charset="0"/>
+                <a:ea typeface="Calibri" pitchFamily="34" charset="-122"/>
+                <a:cs typeface="Calibri" pitchFamily="34" charset="-120"/>
+              </a:rPr>
+              <a:t>≥ 80 %</a:t>
+            </a:r>
+            <a:endParaRPr lang="en-US" sz="3600" dirty="0"/>
+          </a:p>
+        </p:txBody>
+      </p:sp>
+      <p:sp>
+        <p:nvSpPr>
+          <p:cNvPr id="12" name="txt159"/>
+          <p:cNvSpPr txBox="1"/>
+          <p:nvPr/>
+        </p:nvSpPr>
+        <p:spPr>
+          <a:xfrm>
+            <a:off x="4803140" y="2697480"/>
+            <a:ext cx="1638300" cy="914400"/>
+          </a:xfrm>
+          <a:prstGeom prst="rect">
+            <a:avLst/>
+          </a:prstGeom>
+          <a:noFill/>
+          <a:ln/>
+        </p:spPr>
+        <p:txBody>
+          <a:bodyPr wrap="square" lIns="0" tIns="0" rIns="0" bIns="0" rtlCol="0" anchor="t"/>
+          <a:lstStyle/>
+          <a:p>
+            <a:pPr marL="0" indent="0" algn="ctr">
+              <a:buNone/>
+            </a:pPr>
+            <a:r>
+              <a:rPr lang="es-MX" sz="1400">
+                <a:solidFill>
+                  <a:srgbClr val="4A5568"/>
+                </a:solidFill>
+                <a:latin typeface="Calibri" pitchFamily="34" charset="0"/>
+                <a:ea typeface="Calibri" pitchFamily="34" charset="-122"/>
+                <a:cs typeface="Calibri" pitchFamily="34" charset="-120"/>
+              </a:rPr>
+              <a:t>de éxito en UAT (Maze) y SUS ≥ 68</a:t>
+            </a:r>
+            <a:endParaRPr lang="en-US" sz="1400" dirty="0"/>
+          </a:p>
+        </p:txBody>
+      </p:sp>
+      <p:sp>
+        <p:nvSpPr>
+          <p:cNvPr id="13" name="box160"/>
+          <p:cNvSpPr/>
+          <p:nvPr/>
+        </p:nvSpPr>
+        <p:spPr>
+          <a:xfrm>
+            <a:off x="6766560" y="1463040"/>
+            <a:ext cx="1917700" cy="2377440"/>
+          </a:xfrm>
+          <a:prstGeom prst="roundRect">
+            <a:avLst>
+              <a:gd name="adj" fmla="val 3810"/>
+            </a:avLst>
+          </a:prstGeom>
+          <a:solidFill>
+            <a:srgbClr val="EEF2F7"/>
+          </a:solidFill>
+          <a:ln w="12700">
+            <a:solidFill>
+              <a:srgbClr val="EEF2F7"/>
+            </a:solidFill>
+            <a:prstDash val="solid"/>
+          </a:ln>
+        </p:spPr>
+        <p:txBody>
+          <a:bodyPr/>
+          <a:lstStyle/>
+          <a:p>
+            <a:endParaRPr lang="es-PE"/>
+          </a:p>
+        </p:txBody>
+      </p:sp>
+      <p:sp>
+        <p:nvSpPr>
+          <p:cNvPr id="14" name="txt161"/>
+          <p:cNvSpPr txBox="1"/>
+          <p:nvPr/>
+        </p:nvSpPr>
+        <p:spPr>
+          <a:xfrm>
+            <a:off x="6906260" y="1737360"/>
+            <a:ext cx="1638300" cy="822960"/>
+          </a:xfrm>
+          <a:prstGeom prst="rect">
+            <a:avLst/>
+          </a:prstGeom>
+          <a:noFill/>
+          <a:ln/>
+        </p:spPr>
+        <p:txBody>
+          <a:bodyPr wrap="square" lIns="0" tIns="0" rIns="0" bIns="0" rtlCol="0" anchor="ctr"/>
+          <a:lstStyle/>
+          <a:p>
+            <a:pPr marL="0" indent="0" algn="ctr">
+              <a:buNone/>
+            </a:pPr>
+            <a:r>
+              <a:rPr lang="en-US" sz="3600" b="1">
+                <a:solidFill>
+                  <a:srgbClr val="14213D"/>
+                </a:solidFill>
+                <a:latin typeface="Calibri" pitchFamily="34" charset="0"/>
+                <a:ea typeface="Calibri" pitchFamily="34" charset="-122"/>
+                <a:cs typeface="Calibri" pitchFamily="34" charset="-120"/>
+              </a:rPr>
+              <a:t>2</a:t>
+            </a:r>
+            <a:endParaRPr lang="en-US" sz="3600" dirty="0"/>
+          </a:p>
+        </p:txBody>
+      </p:sp>
+      <p:sp>
+        <p:nvSpPr>
+          <p:cNvPr id="15" name="txt162"/>
+          <p:cNvSpPr txBox="1"/>
+          <p:nvPr/>
+        </p:nvSpPr>
+        <p:spPr>
+          <a:xfrm>
+            <a:off x="6906260" y="2697480"/>
+            <a:ext cx="1638300" cy="914400"/>
+          </a:xfrm>
+          <a:prstGeom prst="rect">
+            <a:avLst/>
+          </a:prstGeom>
+          <a:noFill/>
+          <a:ln/>
+        </p:spPr>
+        <p:txBody>
+          <a:bodyPr wrap="square" lIns="0" tIns="0" rIns="0" bIns="0" rtlCol="0" anchor="t"/>
+          <a:lstStyle/>
+          <a:p>
+            <a:pPr marL="0" indent="0" algn="ctr">
+              <a:buNone/>
+            </a:pPr>
+            <a:r>
+              <a:rPr lang="es-MX" sz="1400">
+                <a:solidFill>
+                  <a:srgbClr val="4A5568"/>
+                </a:solidFill>
+                <a:latin typeface="Calibri" pitchFamily="34" charset="0"/>
+                <a:ea typeface="Calibri" pitchFamily="34" charset="-122"/>
+                <a:cs typeface="Calibri" pitchFamily="34" charset="-120"/>
+              </a:rPr>
+              <a:t>firmas: Líder de QA y docente</a:t>
+            </a:r>
+            <a:endParaRPr lang="en-US" sz="1400" dirty="0"/>
+          </a:p>
+        </p:txBody>
+      </p:sp>
+      <p:sp>
+        <p:nvSpPr>
+          <p:cNvPr id="25" name="Slide Number Placeholder 0"/>
+          <p:cNvSpPr>
+            <a:spLocks noGrp="1"/>
+          </p:cNvSpPr>
+          <p:nvPr>
+            <p:ph type="sldNum" sz="quarter" idx="4294967295"/>
+          </p:nvPr>
+        </p:nvSpPr>
+        <p:spPr>
+          <a:xfrm>
+            <a:off x="8229600" y="4754880"/>
+            <a:ext cx="457200" cy="274320"/>
+          </a:xfrm>
+          <a:prstGeom prst="rect">
+            <a:avLst/>
+          </a:prstGeom>
+          <a:extLst>
+            <a:ext uri="{C572A759-6A51-4108-AA02-DFA0A04FC94B}">
+              <ma14:wrappingTextBoxFlag xmlns="" xmlns:ma14="http://schemas.microsoft.com/office/mac/drawingml/2011/main" val="0"/>
+            </a:ext>
+          </a:extLst>
+        </p:spPr>
+        <p:txBody>
+          <a:bodyPr/>
+          <a:lstStyle>
+            <a:lvl1pPr>
+              <a:defRPr sz="1000">
+                <a:solidFill>
+                  <a:srgbClr val="8A94A6"/>
+                </a:solidFill>
+                <a:latin typeface="Calibri"/>
+                <a:ea typeface="Calibri"/>
+                <a:cs typeface="Calibri"/>
+              </a:defRPr>
+            </a:lvl1pPr>
+          </a:lstStyle>
+          <a:p>
+            <a:pPr algn="r"/>
+            <a:fld id="{F7021451-1387-4CA6-816F-3879F97B5CBC}" type="slidenum">
+              <a:rPr lang="en-US" b="0"/>
+              <a:t>19</a:t>
+            </a:fld>
+            <a:endParaRPr lang="en-US"/>
+          </a:p>
+        </p:txBody>
+      </p:sp>
+    </p:spTree>
+    <p:extLst>
+      <p:ext uri="{BB962C8B-B14F-4D97-AF65-F5344CB8AC3E}">
+        <p14:creationId xmlns:p14="http://schemas.microsoft.com/office/powerpoint/2010/main" val="1326869324"/>
+      </p:ext>
+    </p:extLst>
+  </p:cSld>
+  <p:clrMapOvr>
+    <a:masterClrMapping/>
+  </p:clrMapOvr>
+</p:sld>
+</file>
+
+<file path=ppt/slides/slide2.xml><?xml version="1.0" encoding="utf-8"?>
+<p:sld xmlns:a="http://schemas.openxmlformats.org/drawingml/2006/main" xmlns:r="http://schemas.openxmlformats.org/officeDocument/2006/relationships" xmlns:p="http://schemas.openxmlformats.org/presentationml/2006/main">
+  <p:cSld name="Slide 2">
+    <p:spTree>
+      <p:nvGrpSpPr>
+        <p:cNvPr id="1" name=""/>
+        <p:cNvGrpSpPr/>
+        <p:nvPr/>
+      </p:nvGrpSpPr>
+      <p:grpSpPr>
+        <a:xfrm>
+          <a:off x="0" y="0"/>
+          <a:ext cx="0" cy="0"/>
+          <a:chOff x="0" y="0"/>
+          <a:chExt cx="0" cy="0"/>
+        </a:xfrm>
+      </p:grpSpPr>
+      <p:sp>
+        <p:nvSpPr>
+          <p:cNvPr id="2" name="Text 1"/>
+          <p:cNvSpPr>
+            <a:spLocks noGrp="1"/>
+          </p:cNvSpPr>
+          <p:nvPr>
+            <p:ph type="title" idx="101" hasCustomPrompt="1"/>
+          </p:nvPr>
+        </p:nvSpPr>
+        <p:spPr>
+          <a:xfrm>
+            <a:off x="457200" y="274320"/>
+            <a:ext cx="8229600" cy="640080"/>
+          </a:xfrm>
+          <a:prstGeom prst="rect">
+            <a:avLst/>
+          </a:prstGeom>
+          <a:noFill/>
+          <a:ln/>
+        </p:spPr>
+        <p:txBody>
+          <a:bodyPr wrap="square" lIns="0" tIns="0" rIns="0" bIns="0" rtlCol="0" anchor="ctr"/>
+          <a:lstStyle/>
+          <a:p>
+            <a:pPr marL="0" indent="0">
+              <a:buNone/>
+            </a:pPr>
+            <a:r>
+              <a:rPr lang="en-US" sz="2800" b="1" dirty="0">
+                <a:solidFill>
+                  <a:srgbClr val="14213D"/>
+                </a:solidFill>
+                <a:latin typeface="Calibri" pitchFamily="34" charset="0"/>
+                <a:ea typeface="Calibri" pitchFamily="34" charset="-122"/>
+                <a:cs typeface="Calibri" pitchFamily="34" charset="-120"/>
+              </a:rPr>
+              <a:t>TechStore: el sistema bajo evaluación</a:t>
+            </a:r>
+            <a:endParaRPr lang="en-US" sz="2800" dirty="0"/>
+          </a:p>
+        </p:txBody>
+      </p:sp>
+      <p:sp>
+        <p:nvSpPr>
+          <p:cNvPr id="4" name="txt5"/>
+          <p:cNvSpPr txBox="1"/>
+          <p:nvPr/>
+        </p:nvSpPr>
+        <p:spPr>
+          <a:xfrm>
+            <a:off x="457200" y="1188720"/>
+            <a:ext cx="3840480" cy="3291840"/>
+          </a:xfrm>
+          <a:prstGeom prst="rect">
+            <a:avLst/>
+          </a:prstGeom>
+          <a:noFill/>
+          <a:ln/>
+        </p:spPr>
+        <p:txBody>
+          <a:bodyPr wrap="square" lIns="0" tIns="0" rIns="0" bIns="0" rtlCol="0" anchor="t"/>
+          <a:lstStyle/>
+          <a:p>
+            <a:pPr marL="0" indent="0">
+              <a:buNone/>
+            </a:pPr>
+            <a:r>
+              <a:rPr lang="en-US" sz="1500" dirty="0">
+                <a:solidFill>
+                  <a:srgbClr val="4A5568"/>
+                </a:solidFill>
+                <a:latin typeface="Calibri" pitchFamily="34" charset="0"/>
+                <a:ea typeface="Calibri" pitchFamily="34" charset="-122"/>
+                <a:cs typeface="Calibri" pitchFamily="34" charset="-120"/>
+              </a:rPr>
+              <a:t>Tienda web de tecnología: catálogo, carrito, cupones, registro e inicio de sesión, checkout con pago simulado e historial de pedidos.</a:t>
+            </a:r>
+            <a:endParaRPr lang="en-US" sz="1500" dirty="0"/>
+          </a:p>
+          <a:p>
+            <a:pPr marL="0" indent="0">
+              <a:buNone/>
+            </a:pPr>
+            <a:r>
+              <a:rPr lang="en-US" sz="600" dirty="0">
+                <a:solidFill>
+                  <a:srgbClr val="4A5568"/>
+                </a:solidFill>
+                <a:latin typeface="Calibri" pitchFamily="34" charset="0"/>
+                <a:ea typeface="Calibri" pitchFamily="34" charset="-122"/>
+                <a:cs typeface="Calibri" pitchFamily="34" charset="-120"/>
+              </a:rPr>
+              <a:t> </a:t>
+            </a:r>
+            <a:endParaRPr lang="en-US" sz="1500" dirty="0"/>
+          </a:p>
+          <a:p>
+            <a:pPr marL="0" indent="0">
+              <a:buNone/>
+            </a:pPr>
+            <a:r>
+              <a:rPr lang="en-US" sz="1500" b="1" dirty="0">
+                <a:solidFill>
+                  <a:srgbClr val="4A5568"/>
+                </a:solidFill>
+                <a:latin typeface="Calibri" pitchFamily="34" charset="0"/>
+                <a:ea typeface="Calibri" pitchFamily="34" charset="-122"/>
+                <a:cs typeface="Calibri" pitchFamily="34" charset="-120"/>
+              </a:rPr>
+              <a:t>Tecnología: </a:t>
+            </a:r>
+            <a:r>
+              <a:rPr lang="en-US" sz="1500" dirty="0">
+                <a:solidFill>
+                  <a:srgbClr val="4A5568"/>
+                </a:solidFill>
+                <a:latin typeface="Calibri" pitchFamily="34" charset="0"/>
+                <a:ea typeface="Calibri" pitchFamily="34" charset="-122"/>
+                <a:cs typeface="Calibri" pitchFamily="34" charset="-120"/>
+              </a:rPr>
+              <a:t>HTML, CSS y JavaScript puro, sin backend; datos en localStorage.</a:t>
+            </a:r>
+            <a:endParaRPr lang="en-US" sz="1500" dirty="0"/>
+          </a:p>
+          <a:p>
+            <a:pPr marL="0" indent="0">
+              <a:buNone/>
+            </a:pPr>
+            <a:r>
+              <a:rPr lang="en-US" sz="600" dirty="0">
+                <a:solidFill>
+                  <a:srgbClr val="4A5568"/>
+                </a:solidFill>
+                <a:latin typeface="Calibri" pitchFamily="34" charset="0"/>
+                <a:ea typeface="Calibri" pitchFamily="34" charset="-122"/>
+                <a:cs typeface="Calibri" pitchFamily="34" charset="-120"/>
+              </a:rPr>
+              <a:t> </a:t>
+            </a:r>
+            <a:endParaRPr lang="en-US" sz="1500" dirty="0"/>
+          </a:p>
+          <a:p>
+            <a:pPr marL="0" indent="0">
+              <a:buNone/>
+            </a:pPr>
+            <a:r>
+              <a:rPr lang="en-US" sz="1500" b="1" dirty="0">
+                <a:solidFill>
+                  <a:srgbClr val="4A5568"/>
+                </a:solidFill>
+                <a:latin typeface="Calibri" pitchFamily="34" charset="0"/>
+                <a:ea typeface="Calibri" pitchFamily="34" charset="-122"/>
+                <a:cs typeface="Calibri" pitchFamily="34" charset="-120"/>
+              </a:rPr>
+              <a:t>Publicación</a:t>
+            </a:r>
+            <a:r>
+              <a:rPr lang="en-US" sz="1500" b="1">
+                <a:solidFill>
+                  <a:srgbClr val="4A5568"/>
+                </a:solidFill>
+                <a:latin typeface="Calibri" pitchFamily="34" charset="0"/>
+                <a:ea typeface="Calibri" pitchFamily="34" charset="-122"/>
+                <a:cs typeface="Calibri" pitchFamily="34" charset="-120"/>
+              </a:rPr>
+              <a:t>: </a:t>
+            </a:r>
+            <a:r>
+              <a:rPr lang="en-US" sz="1500">
+                <a:solidFill>
+                  <a:srgbClr val="4A5568"/>
+                </a:solidFill>
+                <a:latin typeface="Calibri" pitchFamily="34" charset="0"/>
+                <a:ea typeface="Calibri" pitchFamily="34" charset="-122"/>
+                <a:cs typeface="Calibri" pitchFamily="34" charset="-120"/>
+              </a:rPr>
+              <a:t>GitHub Pages (diegoaaron.github.io/calidadProyecto/).</a:t>
+            </a:r>
+            <a:endParaRPr lang="en-US" sz="1500" dirty="0"/>
+          </a:p>
+          <a:p>
+            <a:pPr marL="0" indent="0">
+              <a:buNone/>
+            </a:pPr>
+            <a:r>
+              <a:rPr lang="en-US" sz="600" dirty="0">
+                <a:solidFill>
+                  <a:srgbClr val="4A5568"/>
+                </a:solidFill>
+                <a:latin typeface="Calibri" pitchFamily="34" charset="0"/>
+                <a:ea typeface="Calibri" pitchFamily="34" charset="-122"/>
+                <a:cs typeface="Calibri" pitchFamily="34" charset="-120"/>
+              </a:rPr>
+              <a:t> </a:t>
+            </a:r>
+            <a:endParaRPr lang="en-US" sz="1500" dirty="0"/>
+          </a:p>
+          <a:p>
+            <a:pPr marL="0" indent="0">
+              <a:buNone/>
+            </a:pPr>
+            <a:r>
+              <a:rPr lang="en-US" sz="1500" b="1" dirty="0">
+                <a:solidFill>
+                  <a:srgbClr val="4A5568"/>
+                </a:solidFill>
+                <a:latin typeface="Calibri" pitchFamily="34" charset="0"/>
+                <a:ea typeface="Calibri" pitchFamily="34" charset="-122"/>
+                <a:cs typeface="Calibri" pitchFamily="34" charset="-120"/>
+              </a:rPr>
+              <a:t>Trazabilidad: </a:t>
+            </a:r>
+            <a:r>
+              <a:rPr lang="en-US" sz="1500" dirty="0">
+                <a:solidFill>
+                  <a:srgbClr val="4A5568"/>
+                </a:solidFill>
+                <a:latin typeface="Calibri" pitchFamily="34" charset="0"/>
+                <a:ea typeface="Calibri" pitchFamily="34" charset="-122"/>
+                <a:cs typeface="Calibri" pitchFamily="34" charset="-120"/>
+              </a:rPr>
+              <a:t>cada métrica, caso de prueba y caso de conformidad apunta a una HU/RF o RNF.</a:t>
+            </a:r>
+            <a:endParaRPr lang="en-US" sz="1500" dirty="0"/>
+          </a:p>
+        </p:txBody>
+      </p:sp>
+      <p:sp>
+        <p:nvSpPr>
+          <p:cNvPr id="5" name="box6"/>
+          <p:cNvSpPr/>
+          <p:nvPr/>
+        </p:nvSpPr>
+        <p:spPr>
+          <a:xfrm>
+            <a:off x="4663440" y="1188720"/>
+            <a:ext cx="1874520" cy="1463040"/>
+          </a:xfrm>
+          <a:prstGeom prst="roundRect">
+            <a:avLst>
+              <a:gd name="adj" fmla="val 5000"/>
+            </a:avLst>
+          </a:prstGeom>
+          <a:solidFill>
+            <a:srgbClr val="EEF2F7"/>
+          </a:solidFill>
+          <a:ln w="12700">
+            <a:solidFill>
+              <a:srgbClr val="EEF2F7"/>
+            </a:solidFill>
+            <a:prstDash val="solid"/>
+          </a:ln>
+        </p:spPr>
+        <p:txBody>
+          <a:bodyPr/>
+          <a:lstStyle/>
+          <a:p>
+            <a:endParaRPr lang="es-PE"/>
+          </a:p>
+        </p:txBody>
+      </p:sp>
+      <p:sp>
+        <p:nvSpPr>
+          <p:cNvPr id="6" name="txt7"/>
+          <p:cNvSpPr txBox="1"/>
+          <p:nvPr/>
+        </p:nvSpPr>
+        <p:spPr>
+          <a:xfrm>
+            <a:off x="4846320" y="1325880"/>
+            <a:ext cx="1554480" cy="731520"/>
+          </a:xfrm>
+          <a:prstGeom prst="rect">
+            <a:avLst/>
+          </a:prstGeom>
+          <a:noFill/>
+          <a:ln/>
+        </p:spPr>
+        <p:txBody>
+          <a:bodyPr wrap="square" lIns="0" tIns="0" rIns="0" bIns="0" rtlCol="0" anchor="t"/>
+          <a:lstStyle/>
+          <a:p>
+            <a:pPr marL="0" indent="0">
+              <a:buNone/>
+            </a:pPr>
+            <a:r>
+              <a:rPr lang="en-US" sz="4400" b="1" dirty="0">
+                <a:solidFill>
+                  <a:srgbClr val="14213D"/>
+                </a:solidFill>
+                <a:latin typeface="Calibri" pitchFamily="34" charset="0"/>
+                <a:ea typeface="Calibri" pitchFamily="34" charset="-122"/>
+                <a:cs typeface="Calibri" pitchFamily="34" charset="-120"/>
+              </a:rPr>
+              <a:t>30</a:t>
+            </a:r>
+            <a:endParaRPr lang="en-US" sz="4400" dirty="0"/>
+          </a:p>
+        </p:txBody>
+      </p:sp>
+      <p:sp>
+        <p:nvSpPr>
+          <p:cNvPr id="7" name="txt8"/>
+          <p:cNvSpPr txBox="1"/>
+          <p:nvPr/>
+        </p:nvSpPr>
+        <p:spPr>
+          <a:xfrm>
+            <a:off x="4846320" y="2057400"/>
+            <a:ext cx="1554480" cy="502920"/>
+          </a:xfrm>
+          <a:prstGeom prst="rect">
+            <a:avLst/>
+          </a:prstGeom>
+          <a:noFill/>
+          <a:ln/>
+        </p:spPr>
+        <p:txBody>
+          <a:bodyPr wrap="square" lIns="0" tIns="0" rIns="0" bIns="0" rtlCol="0" anchor="t"/>
+          <a:lstStyle/>
+          <a:p>
+            <a:pPr marL="0" indent="0">
+              <a:buNone/>
+            </a:pPr>
+            <a:r>
+              <a:rPr lang="en-US" sz="1200" dirty="0">
+                <a:solidFill>
+                  <a:srgbClr val="4A5568"/>
+                </a:solidFill>
+                <a:latin typeface="Calibri" pitchFamily="34" charset="0"/>
+                <a:ea typeface="Calibri" pitchFamily="34" charset="-122"/>
+                <a:cs typeface="Calibri" pitchFamily="34" charset="-120"/>
+              </a:rPr>
+              <a:t>historias de usuario (HU01–HU30)</a:t>
+            </a:r>
+            <a:endParaRPr lang="en-US" sz="1200" dirty="0"/>
+          </a:p>
+        </p:txBody>
+      </p:sp>
+      <p:sp>
+        <p:nvSpPr>
+          <p:cNvPr id="8" name="box9"/>
+          <p:cNvSpPr/>
+          <p:nvPr/>
+        </p:nvSpPr>
+        <p:spPr>
+          <a:xfrm>
+            <a:off x="6720840" y="1188720"/>
+            <a:ext cx="1874520" cy="1463040"/>
+          </a:xfrm>
+          <a:prstGeom prst="roundRect">
+            <a:avLst>
+              <a:gd name="adj" fmla="val 5000"/>
+            </a:avLst>
+          </a:prstGeom>
+          <a:solidFill>
+            <a:srgbClr val="EEF2F7"/>
+          </a:solidFill>
+          <a:ln w="12700">
+            <a:solidFill>
+              <a:srgbClr val="EEF2F7"/>
+            </a:solidFill>
+            <a:prstDash val="solid"/>
+          </a:ln>
+        </p:spPr>
+        <p:txBody>
+          <a:bodyPr/>
+          <a:lstStyle/>
+          <a:p>
+            <a:endParaRPr lang="es-PE"/>
+          </a:p>
+        </p:txBody>
+      </p:sp>
+      <p:sp>
+        <p:nvSpPr>
+          <p:cNvPr id="9" name="txt10"/>
+          <p:cNvSpPr txBox="1"/>
+          <p:nvPr/>
+        </p:nvSpPr>
+        <p:spPr>
+          <a:xfrm>
+            <a:off x="6903720" y="1325880"/>
+            <a:ext cx="1554480" cy="731520"/>
+          </a:xfrm>
+          <a:prstGeom prst="rect">
+            <a:avLst/>
+          </a:prstGeom>
+          <a:noFill/>
+          <a:ln/>
+        </p:spPr>
+        <p:txBody>
+          <a:bodyPr wrap="square" lIns="0" tIns="0" rIns="0" bIns="0" rtlCol="0" anchor="t"/>
+          <a:lstStyle/>
+          <a:p>
+            <a:pPr marL="0" indent="0">
+              <a:buNone/>
+            </a:pPr>
+            <a:r>
+              <a:rPr lang="en-US" sz="4400" b="1" dirty="0">
+                <a:solidFill>
+                  <a:srgbClr val="14213D"/>
+                </a:solidFill>
+                <a:latin typeface="Calibri" pitchFamily="34" charset="0"/>
+                <a:ea typeface="Calibri" pitchFamily="34" charset="-122"/>
+                <a:cs typeface="Calibri" pitchFamily="34" charset="-120"/>
+              </a:rPr>
+              <a:t>5</a:t>
+            </a:r>
+            <a:endParaRPr lang="en-US" sz="4400" dirty="0"/>
+          </a:p>
+        </p:txBody>
+      </p:sp>
+      <p:sp>
+        <p:nvSpPr>
+          <p:cNvPr id="10" name="txt11"/>
+          <p:cNvSpPr txBox="1"/>
+          <p:nvPr/>
+        </p:nvSpPr>
+        <p:spPr>
+          <a:xfrm>
+            <a:off x="6903720" y="2057400"/>
+            <a:ext cx="1554480" cy="502920"/>
+          </a:xfrm>
+          <a:prstGeom prst="rect">
+            <a:avLst/>
+          </a:prstGeom>
+          <a:noFill/>
+          <a:ln/>
+        </p:spPr>
+        <p:txBody>
+          <a:bodyPr wrap="square" lIns="0" tIns="0" rIns="0" bIns="0" rtlCol="0" anchor="t"/>
+          <a:lstStyle/>
+          <a:p>
+            <a:pPr marL="0" indent="0">
+              <a:buNone/>
+            </a:pPr>
+            <a:r>
+              <a:rPr lang="en-US" sz="1200" dirty="0">
+                <a:solidFill>
+                  <a:srgbClr val="4A5568"/>
+                </a:solidFill>
+                <a:latin typeface="Calibri" pitchFamily="34" charset="0"/>
+                <a:ea typeface="Calibri" pitchFamily="34" charset="-122"/>
+                <a:cs typeface="Calibri" pitchFamily="34" charset="-120"/>
+              </a:rPr>
+              <a:t>épicas (EP01–EP05)</a:t>
+            </a:r>
+            <a:endParaRPr lang="en-US" sz="1200" dirty="0"/>
+          </a:p>
+        </p:txBody>
+      </p:sp>
+      <p:sp>
+        <p:nvSpPr>
+          <p:cNvPr id="11" name="box12"/>
+          <p:cNvSpPr/>
+          <p:nvPr/>
+        </p:nvSpPr>
+        <p:spPr>
+          <a:xfrm>
+            <a:off x="4663440" y="2880360"/>
+            <a:ext cx="1874520" cy="1463040"/>
+          </a:xfrm>
+          <a:prstGeom prst="roundRect">
+            <a:avLst>
+              <a:gd name="adj" fmla="val 5000"/>
+            </a:avLst>
+          </a:prstGeom>
+          <a:solidFill>
+            <a:srgbClr val="EEF2F7"/>
+          </a:solidFill>
+          <a:ln w="12700">
+            <a:solidFill>
+              <a:srgbClr val="EEF2F7"/>
+            </a:solidFill>
+            <a:prstDash val="solid"/>
+          </a:ln>
+        </p:spPr>
+        <p:txBody>
+          <a:bodyPr/>
+          <a:lstStyle/>
+          <a:p>
+            <a:endParaRPr lang="es-PE"/>
+          </a:p>
+        </p:txBody>
+      </p:sp>
+      <p:sp>
+        <p:nvSpPr>
+          <p:cNvPr id="12" name="txt13"/>
+          <p:cNvSpPr txBox="1"/>
+          <p:nvPr/>
+        </p:nvSpPr>
+        <p:spPr>
+          <a:xfrm>
+            <a:off x="4846320" y="3017520"/>
+            <a:ext cx="1554480" cy="731520"/>
+          </a:xfrm>
+          <a:prstGeom prst="rect">
+            <a:avLst/>
+          </a:prstGeom>
+          <a:noFill/>
+          <a:ln/>
+        </p:spPr>
+        <p:txBody>
+          <a:bodyPr wrap="square" lIns="0" tIns="0" rIns="0" bIns="0" rtlCol="0" anchor="t"/>
+          <a:lstStyle/>
+          <a:p>
+            <a:pPr marL="0" indent="0">
+              <a:buNone/>
+            </a:pPr>
+            <a:r>
+              <a:rPr lang="en-US" sz="4400" b="1" dirty="0">
+                <a:solidFill>
+                  <a:srgbClr val="14213D"/>
+                </a:solidFill>
+                <a:latin typeface="Calibri" pitchFamily="34" charset="0"/>
+                <a:ea typeface="Calibri" pitchFamily="34" charset="-122"/>
+                <a:cs typeface="Calibri" pitchFamily="34" charset="-120"/>
+              </a:rPr>
+              <a:t>9</a:t>
+            </a:r>
+            <a:endParaRPr lang="en-US" sz="4400" dirty="0"/>
+          </a:p>
+        </p:txBody>
+      </p:sp>
+      <p:sp>
+        <p:nvSpPr>
+          <p:cNvPr id="13" name="txt14"/>
+          <p:cNvSpPr txBox="1"/>
+          <p:nvPr/>
+        </p:nvSpPr>
+        <p:spPr>
+          <a:xfrm>
+            <a:off x="4846320" y="3749040"/>
+            <a:ext cx="1554480" cy="502920"/>
+          </a:xfrm>
+          <a:prstGeom prst="rect">
+            <a:avLst/>
+          </a:prstGeom>
+          <a:noFill/>
+          <a:ln/>
+        </p:spPr>
+        <p:txBody>
+          <a:bodyPr wrap="square" lIns="0" tIns="0" rIns="0" bIns="0" rtlCol="0" anchor="t"/>
+          <a:lstStyle/>
+          <a:p>
+            <a:pPr marL="0" indent="0">
+              <a:buNone/>
+            </a:pPr>
+            <a:r>
+              <a:rPr lang="en-US" sz="1200" dirty="0">
+                <a:solidFill>
+                  <a:srgbClr val="4A5568"/>
+                </a:solidFill>
+                <a:latin typeface="Calibri" pitchFamily="34" charset="0"/>
+                <a:ea typeface="Calibri" pitchFamily="34" charset="-122"/>
+                <a:cs typeface="Calibri" pitchFamily="34" charset="-120"/>
+              </a:rPr>
+              <a:t>requisitos no funcionales</a:t>
+            </a:r>
+            <a:endParaRPr lang="en-US" sz="1200" dirty="0"/>
+          </a:p>
+        </p:txBody>
+      </p:sp>
+      <p:sp>
+        <p:nvSpPr>
+          <p:cNvPr id="14" name="box15"/>
+          <p:cNvSpPr/>
+          <p:nvPr/>
+        </p:nvSpPr>
+        <p:spPr>
+          <a:xfrm>
+            <a:off x="6720840" y="2880360"/>
+            <a:ext cx="1874520" cy="1463040"/>
+          </a:xfrm>
+          <a:prstGeom prst="roundRect">
+            <a:avLst>
+              <a:gd name="adj" fmla="val 5000"/>
+            </a:avLst>
+          </a:prstGeom>
+          <a:solidFill>
+            <a:srgbClr val="EEF2F7"/>
+          </a:solidFill>
+          <a:ln w="12700">
+            <a:solidFill>
+              <a:srgbClr val="EEF2F7"/>
+            </a:solidFill>
+            <a:prstDash val="solid"/>
+          </a:ln>
+        </p:spPr>
+        <p:txBody>
+          <a:bodyPr/>
+          <a:lstStyle/>
+          <a:p>
+            <a:endParaRPr lang="es-PE"/>
+          </a:p>
+        </p:txBody>
+      </p:sp>
+      <p:sp>
+        <p:nvSpPr>
+          <p:cNvPr id="15" name="txt16"/>
+          <p:cNvSpPr txBox="1"/>
+          <p:nvPr/>
+        </p:nvSpPr>
+        <p:spPr>
+          <a:xfrm>
+            <a:off x="6903720" y="3017520"/>
+            <a:ext cx="1554480" cy="731520"/>
+          </a:xfrm>
+          <a:prstGeom prst="rect">
+            <a:avLst/>
+          </a:prstGeom>
+          <a:noFill/>
+          <a:ln/>
+        </p:spPr>
+        <p:txBody>
+          <a:bodyPr wrap="square" lIns="0" tIns="0" rIns="0" bIns="0" rtlCol="0" anchor="t"/>
+          <a:lstStyle/>
+          <a:p>
+            <a:pPr marL="0" indent="0">
+              <a:buNone/>
+            </a:pPr>
+            <a:r>
+              <a:rPr lang="en-US" sz="4400" b="1" dirty="0">
+                <a:solidFill>
+                  <a:srgbClr val="14213D"/>
+                </a:solidFill>
+                <a:latin typeface="Calibri" pitchFamily="34" charset="0"/>
+                <a:ea typeface="Calibri" pitchFamily="34" charset="-122"/>
+                <a:cs typeface="Calibri" pitchFamily="34" charset="-120"/>
+              </a:rPr>
+              <a:t>53</a:t>
+            </a:r>
+            <a:endParaRPr lang="en-US" sz="4400" dirty="0"/>
+          </a:p>
+        </p:txBody>
+      </p:sp>
+      <p:sp>
+        <p:nvSpPr>
+          <p:cNvPr id="16" name="txt17"/>
+          <p:cNvSpPr txBox="1"/>
+          <p:nvPr/>
+        </p:nvSpPr>
+        <p:spPr>
+          <a:xfrm>
+            <a:off x="6903720" y="3749040"/>
+            <a:ext cx="1554480" cy="502920"/>
+          </a:xfrm>
+          <a:prstGeom prst="rect">
+            <a:avLst/>
+          </a:prstGeom>
+          <a:noFill/>
+          <a:ln/>
+        </p:spPr>
+        <p:txBody>
+          <a:bodyPr wrap="square" lIns="0" tIns="0" rIns="0" bIns="0" rtlCol="0" anchor="t"/>
+          <a:lstStyle/>
+          <a:p>
+            <a:pPr marL="0" indent="0">
+              <a:buNone/>
+            </a:pPr>
+            <a:r>
+              <a:rPr lang="en-US" sz="1200" dirty="0">
+                <a:solidFill>
+                  <a:srgbClr val="4A5568"/>
+                </a:solidFill>
+                <a:latin typeface="Calibri" pitchFamily="34" charset="0"/>
+                <a:ea typeface="Calibri" pitchFamily="34" charset="-122"/>
+                <a:cs typeface="Calibri" pitchFamily="34" charset="-120"/>
+              </a:rPr>
+              <a:t>pruebas unitarias automatizadas</a:t>
+            </a:r>
+            <a:endParaRPr lang="en-US" sz="1200" dirty="0"/>
+          </a:p>
+        </p:txBody>
+      </p:sp>
+      <p:sp>
+        <p:nvSpPr>
+          <p:cNvPr id="25" name="Slide Number Placeholder 0"/>
+          <p:cNvSpPr>
+            <a:spLocks noGrp="1"/>
+          </p:cNvSpPr>
+          <p:nvPr>
+            <p:ph type="sldNum" sz="quarter" idx="4294967295"/>
+          </p:nvPr>
+        </p:nvSpPr>
+        <p:spPr>
+          <a:xfrm>
+            <a:off x="8229600" y="4754880"/>
+            <a:ext cx="457200" cy="274320"/>
+          </a:xfrm>
+          <a:prstGeom prst="rect">
+            <a:avLst/>
+          </a:prstGeom>
+          <a:extLst>
+            <a:ext uri="{C572A759-6A51-4108-AA02-DFA0A04FC94B}">
+              <ma14:wrappingTextBoxFlag xmlns:ma14="http://schemas.microsoft.com/office/mac/drawingml/2011/main" xmlns="" val="0"/>
+            </a:ext>
+          </a:extLst>
+        </p:spPr>
+        <p:txBody>
+          <a:bodyPr/>
+          <a:lstStyle>
+            <a:lvl1pPr>
+              <a:defRPr sz="1000">
+                <a:solidFill>
+                  <a:srgbClr val="8A94A6"/>
+                </a:solidFill>
+                <a:latin typeface="Calibri"/>
+                <a:ea typeface="Calibri"/>
+                <a:cs typeface="Calibri"/>
+              </a:defRPr>
+            </a:lvl1pPr>
+          </a:lstStyle>
+          <a:p>
+            <a:pPr algn="r"/>
+            <a:fld id="{F7021451-1387-4CA6-816F-3879F97B5CBC}" type="slidenum">
+              <a:rPr lang="en-US" b="0"/>
+              <a:t>2</a:t>
+            </a:fld>
+            <a:endParaRPr lang="en-US"/>
+          </a:p>
+        </p:txBody>
+      </p:sp>
+    </p:spTree>
+  </p:cSld>
+  <p:clrMapOvr>
+    <a:masterClrMapping/>
+  </p:clrMapOvr>
+</p:sld>
+</file>
+
+<file path=ppt/slides/slide20.xml><?xml version="1.0" encoding="utf-8"?>
 <p:sld xmlns:a="http://schemas.openxmlformats.org/drawingml/2006/main" xmlns:r="http://schemas.openxmlformats.org/officeDocument/2006/relationships" xmlns:p="http://schemas.openxmlformats.org/presentationml/2006/main">
   <p:cSld name="Slide 18">
     <p:spTree>
@@ -15034,7 +17424,7 @@
 </p:sld>
 </file>
 
-<file path=ppt/slides/slide19.xml><?xml version="1.0" encoding="utf-8"?>
+<file path=ppt/slides/slide21.xml><?xml version="1.0" encoding="utf-8"?>
 <p:sld xmlns:a="http://schemas.openxmlformats.org/drawingml/2006/main" xmlns:r="http://schemas.openxmlformats.org/officeDocument/2006/relationships" xmlns:p="http://schemas.openxmlformats.org/presentationml/2006/main">
   <p:cSld name="Slide 19">
     <p:spTree>
@@ -17145,7 +19535,7 @@
             <a:pPr algn="r"/>
             <a:fld id="{F7021451-1387-4CA6-816F-3879F97B5CBC}" type="slidenum">
               <a:rPr lang="en-US" b="0"/>
-              <a:t>19</a:t>
+              <a:t>21</a:t>
             </a:fld>
             <a:endParaRPr lang="en-US"/>
           </a:p>
@@ -17159,745 +19549,7 @@
 </p:sld>
 </file>
 
-<file path=ppt/slides/slide2.xml><?xml version="1.0" encoding="utf-8"?>
-<p:sld xmlns:a="http://schemas.openxmlformats.org/drawingml/2006/main" xmlns:r="http://schemas.openxmlformats.org/officeDocument/2006/relationships" xmlns:p="http://schemas.openxmlformats.org/presentationml/2006/main">
-  <p:cSld name="Slide 2">
-    <p:spTree>
-      <p:nvGrpSpPr>
-        <p:cNvPr id="1" name=""/>
-        <p:cNvGrpSpPr/>
-        <p:nvPr/>
-      </p:nvGrpSpPr>
-      <p:grpSpPr>
-        <a:xfrm>
-          <a:off x="0" y="0"/>
-          <a:ext cx="0" cy="0"/>
-          <a:chOff x="0" y="0"/>
-          <a:chExt cx="0" cy="0"/>
-        </a:xfrm>
-      </p:grpSpPr>
-      <p:sp>
-        <p:nvSpPr>
-          <p:cNvPr id="2" name="Text 1"/>
-          <p:cNvSpPr>
-            <a:spLocks noGrp="1"/>
-          </p:cNvSpPr>
-          <p:nvPr>
-            <p:ph type="title" idx="101" hasCustomPrompt="1"/>
-          </p:nvPr>
-        </p:nvSpPr>
-        <p:spPr>
-          <a:xfrm>
-            <a:off x="457200" y="274320"/>
-            <a:ext cx="8229600" cy="640080"/>
-          </a:xfrm>
-          <a:prstGeom prst="rect">
-            <a:avLst/>
-          </a:prstGeom>
-          <a:noFill/>
-          <a:ln/>
-        </p:spPr>
-        <p:txBody>
-          <a:bodyPr wrap="square" lIns="0" tIns="0" rIns="0" bIns="0" rtlCol="0" anchor="ctr"/>
-          <a:lstStyle/>
-          <a:p>
-            <a:pPr marL="0" indent="0">
-              <a:buNone/>
-            </a:pPr>
-            <a:r>
-              <a:rPr lang="en-US" sz="2800" b="1" dirty="0">
-                <a:solidFill>
-                  <a:srgbClr val="14213D"/>
-                </a:solidFill>
-                <a:latin typeface="Calibri" pitchFamily="34" charset="0"/>
-                <a:ea typeface="Calibri" pitchFamily="34" charset="-122"/>
-                <a:cs typeface="Calibri" pitchFamily="34" charset="-120"/>
-              </a:rPr>
-              <a:t>TechStore: el sistema bajo evaluación</a:t>
-            </a:r>
-            <a:endParaRPr lang="en-US" sz="2800" dirty="0"/>
-          </a:p>
-        </p:txBody>
-      </p:sp>
-      <p:sp>
-        <p:nvSpPr>
-          <p:cNvPr id="4" name="txt5"/>
-          <p:cNvSpPr txBox="1"/>
-          <p:nvPr/>
-        </p:nvSpPr>
-        <p:spPr>
-          <a:xfrm>
-            <a:off x="457200" y="1188720"/>
-            <a:ext cx="3840480" cy="3291840"/>
-          </a:xfrm>
-          <a:prstGeom prst="rect">
-            <a:avLst/>
-          </a:prstGeom>
-          <a:noFill/>
-          <a:ln/>
-        </p:spPr>
-        <p:txBody>
-          <a:bodyPr wrap="square" lIns="0" tIns="0" rIns="0" bIns="0" rtlCol="0" anchor="t"/>
-          <a:lstStyle/>
-          <a:p>
-            <a:pPr marL="0" indent="0">
-              <a:buNone/>
-            </a:pPr>
-            <a:r>
-              <a:rPr lang="en-US" sz="1500" dirty="0">
-                <a:solidFill>
-                  <a:srgbClr val="4A5568"/>
-                </a:solidFill>
-                <a:latin typeface="Calibri" pitchFamily="34" charset="0"/>
-                <a:ea typeface="Calibri" pitchFamily="34" charset="-122"/>
-                <a:cs typeface="Calibri" pitchFamily="34" charset="-120"/>
-              </a:rPr>
-              <a:t>Tienda web de tecnología: catálogo, carrito, cupones, registro e inicio de sesión, checkout con pago simulado e historial de pedidos.</a:t>
-            </a:r>
-            <a:endParaRPr lang="en-US" sz="1500" dirty="0"/>
-          </a:p>
-          <a:p>
-            <a:pPr marL="0" indent="0">
-              <a:buNone/>
-            </a:pPr>
-            <a:r>
-              <a:rPr lang="en-US" sz="600" dirty="0">
-                <a:solidFill>
-                  <a:srgbClr val="4A5568"/>
-                </a:solidFill>
-                <a:latin typeface="Calibri" pitchFamily="34" charset="0"/>
-                <a:ea typeface="Calibri" pitchFamily="34" charset="-122"/>
-                <a:cs typeface="Calibri" pitchFamily="34" charset="-120"/>
-              </a:rPr>
-              <a:t> </a:t>
-            </a:r>
-            <a:endParaRPr lang="en-US" sz="1500" dirty="0"/>
-          </a:p>
-          <a:p>
-            <a:pPr marL="0" indent="0">
-              <a:buNone/>
-            </a:pPr>
-            <a:r>
-              <a:rPr lang="en-US" sz="1500" b="1" dirty="0">
-                <a:solidFill>
-                  <a:srgbClr val="4A5568"/>
-                </a:solidFill>
-                <a:latin typeface="Calibri" pitchFamily="34" charset="0"/>
-                <a:ea typeface="Calibri" pitchFamily="34" charset="-122"/>
-                <a:cs typeface="Calibri" pitchFamily="34" charset="-120"/>
-              </a:rPr>
-              <a:t>Tecnología: </a:t>
-            </a:r>
-            <a:r>
-              <a:rPr lang="en-US" sz="1500" dirty="0">
-                <a:solidFill>
-                  <a:srgbClr val="4A5568"/>
-                </a:solidFill>
-                <a:latin typeface="Calibri" pitchFamily="34" charset="0"/>
-                <a:ea typeface="Calibri" pitchFamily="34" charset="-122"/>
-                <a:cs typeface="Calibri" pitchFamily="34" charset="-120"/>
-              </a:rPr>
-              <a:t>HTML, CSS y JavaScript puro, sin backend; datos en localStorage.</a:t>
-            </a:r>
-            <a:endParaRPr lang="en-US" sz="1500" dirty="0"/>
-          </a:p>
-          <a:p>
-            <a:pPr marL="0" indent="0">
-              <a:buNone/>
-            </a:pPr>
-            <a:r>
-              <a:rPr lang="en-US" sz="600" dirty="0">
-                <a:solidFill>
-                  <a:srgbClr val="4A5568"/>
-                </a:solidFill>
-                <a:latin typeface="Calibri" pitchFamily="34" charset="0"/>
-                <a:ea typeface="Calibri" pitchFamily="34" charset="-122"/>
-                <a:cs typeface="Calibri" pitchFamily="34" charset="-120"/>
-              </a:rPr>
-              <a:t> </a:t>
-            </a:r>
-            <a:endParaRPr lang="en-US" sz="1500" dirty="0"/>
-          </a:p>
-          <a:p>
-            <a:pPr marL="0" indent="0">
-              <a:buNone/>
-            </a:pPr>
-            <a:r>
-              <a:rPr lang="en-US" sz="1500" b="1" dirty="0">
-                <a:solidFill>
-                  <a:srgbClr val="4A5568"/>
-                </a:solidFill>
-                <a:latin typeface="Calibri" pitchFamily="34" charset="0"/>
-                <a:ea typeface="Calibri" pitchFamily="34" charset="-122"/>
-                <a:cs typeface="Calibri" pitchFamily="34" charset="-120"/>
-              </a:rPr>
-              <a:t>Publicación: </a:t>
-            </a:r>
-            <a:r>
-              <a:rPr lang="en-US" sz="1500" dirty="0">
-                <a:solidFill>
-                  <a:srgbClr val="4A5568"/>
-                </a:solidFill>
-                <a:latin typeface="Calibri" pitchFamily="34" charset="0"/>
-                <a:ea typeface="Calibri" pitchFamily="34" charset="-122"/>
-                <a:cs typeface="Calibri" pitchFamily="34" charset="-120"/>
-              </a:rPr>
-              <a:t>GitHub Pages.</a:t>
-            </a:r>
-            <a:endParaRPr lang="en-US" sz="1500" dirty="0"/>
-          </a:p>
-          <a:p>
-            <a:pPr marL="0" indent="0">
-              <a:buNone/>
-            </a:pPr>
-            <a:r>
-              <a:rPr lang="en-US" sz="600" dirty="0">
-                <a:solidFill>
-                  <a:srgbClr val="4A5568"/>
-                </a:solidFill>
-                <a:latin typeface="Calibri" pitchFamily="34" charset="0"/>
-                <a:ea typeface="Calibri" pitchFamily="34" charset="-122"/>
-                <a:cs typeface="Calibri" pitchFamily="34" charset="-120"/>
-              </a:rPr>
-              <a:t> </a:t>
-            </a:r>
-            <a:endParaRPr lang="en-US" sz="1500" dirty="0"/>
-          </a:p>
-          <a:p>
-            <a:pPr marL="0" indent="0">
-              <a:buNone/>
-            </a:pPr>
-            <a:r>
-              <a:rPr lang="en-US" sz="1500" b="1" dirty="0">
-                <a:solidFill>
-                  <a:srgbClr val="4A5568"/>
-                </a:solidFill>
-                <a:latin typeface="Calibri" pitchFamily="34" charset="0"/>
-                <a:ea typeface="Calibri" pitchFamily="34" charset="-122"/>
-                <a:cs typeface="Calibri" pitchFamily="34" charset="-120"/>
-              </a:rPr>
-              <a:t>Trazabilidad: </a:t>
-            </a:r>
-            <a:r>
-              <a:rPr lang="en-US" sz="1500" dirty="0">
-                <a:solidFill>
-                  <a:srgbClr val="4A5568"/>
-                </a:solidFill>
-                <a:latin typeface="Calibri" pitchFamily="34" charset="0"/>
-                <a:ea typeface="Calibri" pitchFamily="34" charset="-122"/>
-                <a:cs typeface="Calibri" pitchFamily="34" charset="-120"/>
-              </a:rPr>
-              <a:t>cada métrica, caso de prueba y caso de conformidad apunta a una HU/RF o RNF.</a:t>
-            </a:r>
-            <a:endParaRPr lang="en-US" sz="1500" dirty="0"/>
-          </a:p>
-        </p:txBody>
-      </p:sp>
-      <p:sp>
-        <p:nvSpPr>
-          <p:cNvPr id="5" name="box6"/>
-          <p:cNvSpPr/>
-          <p:nvPr/>
-        </p:nvSpPr>
-        <p:spPr>
-          <a:xfrm>
-            <a:off x="4663440" y="1188720"/>
-            <a:ext cx="1874520" cy="1463040"/>
-          </a:xfrm>
-          <a:prstGeom prst="roundRect">
-            <a:avLst>
-              <a:gd name="adj" fmla="val 5000"/>
-            </a:avLst>
-          </a:prstGeom>
-          <a:solidFill>
-            <a:srgbClr val="EEF2F7"/>
-          </a:solidFill>
-          <a:ln w="12700">
-            <a:solidFill>
-              <a:srgbClr val="EEF2F7"/>
-            </a:solidFill>
-            <a:prstDash val="solid"/>
-          </a:ln>
-        </p:spPr>
-        <p:txBody>
-          <a:bodyPr/>
-          <a:lstStyle/>
-          <a:p>
-            <a:endParaRPr lang="es-PE"/>
-          </a:p>
-        </p:txBody>
-      </p:sp>
-      <p:sp>
-        <p:nvSpPr>
-          <p:cNvPr id="6" name="txt7"/>
-          <p:cNvSpPr txBox="1"/>
-          <p:nvPr/>
-        </p:nvSpPr>
-        <p:spPr>
-          <a:xfrm>
-            <a:off x="4846320" y="1325880"/>
-            <a:ext cx="1554480" cy="731520"/>
-          </a:xfrm>
-          <a:prstGeom prst="rect">
-            <a:avLst/>
-          </a:prstGeom>
-          <a:noFill/>
-          <a:ln/>
-        </p:spPr>
-        <p:txBody>
-          <a:bodyPr wrap="square" lIns="0" tIns="0" rIns="0" bIns="0" rtlCol="0" anchor="t"/>
-          <a:lstStyle/>
-          <a:p>
-            <a:pPr marL="0" indent="0">
-              <a:buNone/>
-            </a:pPr>
-            <a:r>
-              <a:rPr lang="en-US" sz="4400" b="1" dirty="0">
-                <a:solidFill>
-                  <a:srgbClr val="14213D"/>
-                </a:solidFill>
-                <a:latin typeface="Calibri" pitchFamily="34" charset="0"/>
-                <a:ea typeface="Calibri" pitchFamily="34" charset="-122"/>
-                <a:cs typeface="Calibri" pitchFamily="34" charset="-120"/>
-              </a:rPr>
-              <a:t>30</a:t>
-            </a:r>
-            <a:endParaRPr lang="en-US" sz="4400" dirty="0"/>
-          </a:p>
-        </p:txBody>
-      </p:sp>
-      <p:sp>
-        <p:nvSpPr>
-          <p:cNvPr id="7" name="txt8"/>
-          <p:cNvSpPr txBox="1"/>
-          <p:nvPr/>
-        </p:nvSpPr>
-        <p:spPr>
-          <a:xfrm>
-            <a:off x="4846320" y="2057400"/>
-            <a:ext cx="1554480" cy="502920"/>
-          </a:xfrm>
-          <a:prstGeom prst="rect">
-            <a:avLst/>
-          </a:prstGeom>
-          <a:noFill/>
-          <a:ln/>
-        </p:spPr>
-        <p:txBody>
-          <a:bodyPr wrap="square" lIns="0" tIns="0" rIns="0" bIns="0" rtlCol="0" anchor="t"/>
-          <a:lstStyle/>
-          <a:p>
-            <a:pPr marL="0" indent="0">
-              <a:buNone/>
-            </a:pPr>
-            <a:r>
-              <a:rPr lang="en-US" sz="1200" dirty="0">
-                <a:solidFill>
-                  <a:srgbClr val="4A5568"/>
-                </a:solidFill>
-                <a:latin typeface="Calibri" pitchFamily="34" charset="0"/>
-                <a:ea typeface="Calibri" pitchFamily="34" charset="-122"/>
-                <a:cs typeface="Calibri" pitchFamily="34" charset="-120"/>
-              </a:rPr>
-              <a:t>historias de usuario (HU01–HU30)</a:t>
-            </a:r>
-            <a:endParaRPr lang="en-US" sz="1200" dirty="0"/>
-          </a:p>
-        </p:txBody>
-      </p:sp>
-      <p:sp>
-        <p:nvSpPr>
-          <p:cNvPr id="8" name="box9"/>
-          <p:cNvSpPr/>
-          <p:nvPr/>
-        </p:nvSpPr>
-        <p:spPr>
-          <a:xfrm>
-            <a:off x="6720840" y="1188720"/>
-            <a:ext cx="1874520" cy="1463040"/>
-          </a:xfrm>
-          <a:prstGeom prst="roundRect">
-            <a:avLst>
-              <a:gd name="adj" fmla="val 5000"/>
-            </a:avLst>
-          </a:prstGeom>
-          <a:solidFill>
-            <a:srgbClr val="EEF2F7"/>
-          </a:solidFill>
-          <a:ln w="12700">
-            <a:solidFill>
-              <a:srgbClr val="EEF2F7"/>
-            </a:solidFill>
-            <a:prstDash val="solid"/>
-          </a:ln>
-        </p:spPr>
-        <p:txBody>
-          <a:bodyPr/>
-          <a:lstStyle/>
-          <a:p>
-            <a:endParaRPr lang="es-PE"/>
-          </a:p>
-        </p:txBody>
-      </p:sp>
-      <p:sp>
-        <p:nvSpPr>
-          <p:cNvPr id="9" name="txt10"/>
-          <p:cNvSpPr txBox="1"/>
-          <p:nvPr/>
-        </p:nvSpPr>
-        <p:spPr>
-          <a:xfrm>
-            <a:off x="6903720" y="1325880"/>
-            <a:ext cx="1554480" cy="731520"/>
-          </a:xfrm>
-          <a:prstGeom prst="rect">
-            <a:avLst/>
-          </a:prstGeom>
-          <a:noFill/>
-          <a:ln/>
-        </p:spPr>
-        <p:txBody>
-          <a:bodyPr wrap="square" lIns="0" tIns="0" rIns="0" bIns="0" rtlCol="0" anchor="t"/>
-          <a:lstStyle/>
-          <a:p>
-            <a:pPr marL="0" indent="0">
-              <a:buNone/>
-            </a:pPr>
-            <a:r>
-              <a:rPr lang="en-US" sz="4400" b="1" dirty="0">
-                <a:solidFill>
-                  <a:srgbClr val="14213D"/>
-                </a:solidFill>
-                <a:latin typeface="Calibri" pitchFamily="34" charset="0"/>
-                <a:ea typeface="Calibri" pitchFamily="34" charset="-122"/>
-                <a:cs typeface="Calibri" pitchFamily="34" charset="-120"/>
-              </a:rPr>
-              <a:t>5</a:t>
-            </a:r>
-            <a:endParaRPr lang="en-US" sz="4400" dirty="0"/>
-          </a:p>
-        </p:txBody>
-      </p:sp>
-      <p:sp>
-        <p:nvSpPr>
-          <p:cNvPr id="10" name="txt11"/>
-          <p:cNvSpPr txBox="1"/>
-          <p:nvPr/>
-        </p:nvSpPr>
-        <p:spPr>
-          <a:xfrm>
-            <a:off x="6903720" y="2057400"/>
-            <a:ext cx="1554480" cy="502920"/>
-          </a:xfrm>
-          <a:prstGeom prst="rect">
-            <a:avLst/>
-          </a:prstGeom>
-          <a:noFill/>
-          <a:ln/>
-        </p:spPr>
-        <p:txBody>
-          <a:bodyPr wrap="square" lIns="0" tIns="0" rIns="0" bIns="0" rtlCol="0" anchor="t"/>
-          <a:lstStyle/>
-          <a:p>
-            <a:pPr marL="0" indent="0">
-              <a:buNone/>
-            </a:pPr>
-            <a:r>
-              <a:rPr lang="en-US" sz="1200" dirty="0">
-                <a:solidFill>
-                  <a:srgbClr val="4A5568"/>
-                </a:solidFill>
-                <a:latin typeface="Calibri" pitchFamily="34" charset="0"/>
-                <a:ea typeface="Calibri" pitchFamily="34" charset="-122"/>
-                <a:cs typeface="Calibri" pitchFamily="34" charset="-120"/>
-              </a:rPr>
-              <a:t>épicas (EP01–EP05)</a:t>
-            </a:r>
-            <a:endParaRPr lang="en-US" sz="1200" dirty="0"/>
-          </a:p>
-        </p:txBody>
-      </p:sp>
-      <p:sp>
-        <p:nvSpPr>
-          <p:cNvPr id="11" name="box12"/>
-          <p:cNvSpPr/>
-          <p:nvPr/>
-        </p:nvSpPr>
-        <p:spPr>
-          <a:xfrm>
-            <a:off x="4663440" y="2880360"/>
-            <a:ext cx="1874520" cy="1463040"/>
-          </a:xfrm>
-          <a:prstGeom prst="roundRect">
-            <a:avLst>
-              <a:gd name="adj" fmla="val 5000"/>
-            </a:avLst>
-          </a:prstGeom>
-          <a:solidFill>
-            <a:srgbClr val="EEF2F7"/>
-          </a:solidFill>
-          <a:ln w="12700">
-            <a:solidFill>
-              <a:srgbClr val="EEF2F7"/>
-            </a:solidFill>
-            <a:prstDash val="solid"/>
-          </a:ln>
-        </p:spPr>
-        <p:txBody>
-          <a:bodyPr/>
-          <a:lstStyle/>
-          <a:p>
-            <a:endParaRPr lang="es-PE"/>
-          </a:p>
-        </p:txBody>
-      </p:sp>
-      <p:sp>
-        <p:nvSpPr>
-          <p:cNvPr id="12" name="txt13"/>
-          <p:cNvSpPr txBox="1"/>
-          <p:nvPr/>
-        </p:nvSpPr>
-        <p:spPr>
-          <a:xfrm>
-            <a:off x="4846320" y="3017520"/>
-            <a:ext cx="1554480" cy="731520"/>
-          </a:xfrm>
-          <a:prstGeom prst="rect">
-            <a:avLst/>
-          </a:prstGeom>
-          <a:noFill/>
-          <a:ln/>
-        </p:spPr>
-        <p:txBody>
-          <a:bodyPr wrap="square" lIns="0" tIns="0" rIns="0" bIns="0" rtlCol="0" anchor="t"/>
-          <a:lstStyle/>
-          <a:p>
-            <a:pPr marL="0" indent="0">
-              <a:buNone/>
-            </a:pPr>
-            <a:r>
-              <a:rPr lang="en-US" sz="4400" b="1" dirty="0">
-                <a:solidFill>
-                  <a:srgbClr val="14213D"/>
-                </a:solidFill>
-                <a:latin typeface="Calibri" pitchFamily="34" charset="0"/>
-                <a:ea typeface="Calibri" pitchFamily="34" charset="-122"/>
-                <a:cs typeface="Calibri" pitchFamily="34" charset="-120"/>
-              </a:rPr>
-              <a:t>9</a:t>
-            </a:r>
-            <a:endParaRPr lang="en-US" sz="4400" dirty="0"/>
-          </a:p>
-        </p:txBody>
-      </p:sp>
-      <p:sp>
-        <p:nvSpPr>
-          <p:cNvPr id="13" name="txt14"/>
-          <p:cNvSpPr txBox="1"/>
-          <p:nvPr/>
-        </p:nvSpPr>
-        <p:spPr>
-          <a:xfrm>
-            <a:off x="4846320" y="3749040"/>
-            <a:ext cx="1554480" cy="502920"/>
-          </a:xfrm>
-          <a:prstGeom prst="rect">
-            <a:avLst/>
-          </a:prstGeom>
-          <a:noFill/>
-          <a:ln/>
-        </p:spPr>
-        <p:txBody>
-          <a:bodyPr wrap="square" lIns="0" tIns="0" rIns="0" bIns="0" rtlCol="0" anchor="t"/>
-          <a:lstStyle/>
-          <a:p>
-            <a:pPr marL="0" indent="0">
-              <a:buNone/>
-            </a:pPr>
-            <a:r>
-              <a:rPr lang="en-US" sz="1200" dirty="0">
-                <a:solidFill>
-                  <a:srgbClr val="4A5568"/>
-                </a:solidFill>
-                <a:latin typeface="Calibri" pitchFamily="34" charset="0"/>
-                <a:ea typeface="Calibri" pitchFamily="34" charset="-122"/>
-                <a:cs typeface="Calibri" pitchFamily="34" charset="-120"/>
-              </a:rPr>
-              <a:t>requisitos no funcionales</a:t>
-            </a:r>
-            <a:endParaRPr lang="en-US" sz="1200" dirty="0"/>
-          </a:p>
-        </p:txBody>
-      </p:sp>
-      <p:sp>
-        <p:nvSpPr>
-          <p:cNvPr id="14" name="box15"/>
-          <p:cNvSpPr/>
-          <p:nvPr/>
-        </p:nvSpPr>
-        <p:spPr>
-          <a:xfrm>
-            <a:off x="6720840" y="2880360"/>
-            <a:ext cx="1874520" cy="1463040"/>
-          </a:xfrm>
-          <a:prstGeom prst="roundRect">
-            <a:avLst>
-              <a:gd name="adj" fmla="val 5000"/>
-            </a:avLst>
-          </a:prstGeom>
-          <a:solidFill>
-            <a:srgbClr val="EEF2F7"/>
-          </a:solidFill>
-          <a:ln w="12700">
-            <a:solidFill>
-              <a:srgbClr val="EEF2F7"/>
-            </a:solidFill>
-            <a:prstDash val="solid"/>
-          </a:ln>
-        </p:spPr>
-        <p:txBody>
-          <a:bodyPr/>
-          <a:lstStyle/>
-          <a:p>
-            <a:endParaRPr lang="es-PE"/>
-          </a:p>
-        </p:txBody>
-      </p:sp>
-      <p:sp>
-        <p:nvSpPr>
-          <p:cNvPr id="15" name="txt16"/>
-          <p:cNvSpPr txBox="1"/>
-          <p:nvPr/>
-        </p:nvSpPr>
-        <p:spPr>
-          <a:xfrm>
-            <a:off x="6903720" y="3017520"/>
-            <a:ext cx="1554480" cy="731520"/>
-          </a:xfrm>
-          <a:prstGeom prst="rect">
-            <a:avLst/>
-          </a:prstGeom>
-          <a:noFill/>
-          <a:ln/>
-        </p:spPr>
-        <p:txBody>
-          <a:bodyPr wrap="square" lIns="0" tIns="0" rIns="0" bIns="0" rtlCol="0" anchor="t"/>
-          <a:lstStyle/>
-          <a:p>
-            <a:pPr marL="0" indent="0">
-              <a:buNone/>
-            </a:pPr>
-            <a:r>
-              <a:rPr lang="en-US" sz="4400" b="1" dirty="0">
-                <a:solidFill>
-                  <a:srgbClr val="14213D"/>
-                </a:solidFill>
-                <a:latin typeface="Calibri" pitchFamily="34" charset="0"/>
-                <a:ea typeface="Calibri" pitchFamily="34" charset="-122"/>
-                <a:cs typeface="Calibri" pitchFamily="34" charset="-120"/>
-              </a:rPr>
-              <a:t>53</a:t>
-            </a:r>
-            <a:endParaRPr lang="en-US" sz="4400" dirty="0"/>
-          </a:p>
-        </p:txBody>
-      </p:sp>
-      <p:sp>
-        <p:nvSpPr>
-          <p:cNvPr id="16" name="txt17"/>
-          <p:cNvSpPr txBox="1"/>
-          <p:nvPr/>
-        </p:nvSpPr>
-        <p:spPr>
-          <a:xfrm>
-            <a:off x="6903720" y="3749040"/>
-            <a:ext cx="1554480" cy="502920"/>
-          </a:xfrm>
-          <a:prstGeom prst="rect">
-            <a:avLst/>
-          </a:prstGeom>
-          <a:noFill/>
-          <a:ln/>
-        </p:spPr>
-        <p:txBody>
-          <a:bodyPr wrap="square" lIns="0" tIns="0" rIns="0" bIns="0" rtlCol="0" anchor="t"/>
-          <a:lstStyle/>
-          <a:p>
-            <a:pPr marL="0" indent="0">
-              <a:buNone/>
-            </a:pPr>
-            <a:r>
-              <a:rPr lang="en-US" sz="1200" dirty="0">
-                <a:solidFill>
-                  <a:srgbClr val="4A5568"/>
-                </a:solidFill>
-                <a:latin typeface="Calibri" pitchFamily="34" charset="0"/>
-                <a:ea typeface="Calibri" pitchFamily="34" charset="-122"/>
-                <a:cs typeface="Calibri" pitchFamily="34" charset="-120"/>
-              </a:rPr>
-              <a:t>pruebas unitarias automatizadas</a:t>
-            </a:r>
-            <a:endParaRPr lang="en-US" sz="1200" dirty="0"/>
-          </a:p>
-        </p:txBody>
-      </p:sp>
-      <p:sp>
-        <p:nvSpPr>
-          <p:cNvPr id="25" name="Slide Number Placeholder 0"/>
-          <p:cNvSpPr>
-            <a:spLocks noGrp="1"/>
-          </p:cNvSpPr>
-          <p:nvPr>
-            <p:ph type="sldNum" sz="quarter" idx="4294967295"/>
-          </p:nvPr>
-        </p:nvSpPr>
-        <p:spPr>
-          <a:xfrm>
-            <a:off x="8229600" y="4754880"/>
-            <a:ext cx="457200" cy="274320"/>
-          </a:xfrm>
-          <a:prstGeom prst="rect">
-            <a:avLst/>
-          </a:prstGeom>
-          <a:extLst>
-            <a:ext uri="{C572A759-6A51-4108-AA02-DFA0A04FC94B}">
-              <ma14:wrappingTextBoxFlag xmlns:ma14="http://schemas.microsoft.com/office/mac/drawingml/2011/main" xmlns="" val="0"/>
-            </a:ext>
-          </a:extLst>
-        </p:spPr>
-        <p:txBody>
-          <a:bodyPr/>
-          <a:lstStyle>
-            <a:lvl1pPr>
-              <a:defRPr sz="1000">
-                <a:solidFill>
-                  <a:srgbClr val="8A94A6"/>
-                </a:solidFill>
-                <a:latin typeface="Calibri"/>
-                <a:ea typeface="Calibri"/>
-                <a:cs typeface="Calibri"/>
-              </a:defRPr>
-            </a:lvl1pPr>
-          </a:lstStyle>
-          <a:p>
-            <a:pPr algn="r"/>
-            <a:fld id="{F7021451-1387-4CA6-816F-3879F97B5CBC}" type="slidenum">
-              <a:rPr lang="en-US" b="0"/>
-              <a:t>2</a:t>
-            </a:fld>
-            <a:endParaRPr lang="en-US"/>
-          </a:p>
-        </p:txBody>
-      </p:sp>
-    </p:spTree>
-  </p:cSld>
-  <p:clrMapOvr>
-    <a:masterClrMapping/>
-  </p:clrMapOvr>
-</p:sld>
-</file>
-
-<file path=ppt/slides/slide20.xml><?xml version="1.0" encoding="utf-8"?>
+<file path=ppt/slides/slide22.xml><?xml version="1.0" encoding="utf-8"?>
 <p:sld xmlns:a="http://schemas.openxmlformats.org/drawingml/2006/main" xmlns:r="http://schemas.openxmlformats.org/officeDocument/2006/relationships" xmlns:p="http://schemas.openxmlformats.org/presentationml/2006/main">
   <p:cSld name="Slide 20">
     <p:spTree>
@@ -19329,7 +20981,7 @@
             <a:pPr algn="r"/>
             <a:fld id="{F7021451-1387-4CA6-816F-3879F97B5CBC}" type="slidenum">
               <a:rPr lang="en-US" b="0"/>
-              <a:t>20</a:t>
+              <a:t>22</a:t>
             </a:fld>
             <a:endParaRPr lang="en-US"/>
           </a:p>
@@ -19343,7 +20995,7 @@
 </p:sld>
 </file>
 
-<file path=ppt/slides/slide21.xml><?xml version="1.0" encoding="utf-8"?>
+<file path=ppt/slides/slide23.xml><?xml version="1.0" encoding="utf-8"?>
 <p:sld xmlns:a="http://schemas.openxmlformats.org/drawingml/2006/main" xmlns:r="http://schemas.openxmlformats.org/officeDocument/2006/relationships" xmlns:p="http://schemas.openxmlformats.org/presentationml/2006/main">
   <p:cSld name="Slide 21">
     <p:spTree>
@@ -20865,7 +22517,7 @@
             <a:pPr algn="r"/>
             <a:fld id="{F7021451-1387-4CA6-816F-3879F97B5CBC}" type="slidenum">
               <a:rPr lang="en-US" b="0"/>
-              <a:t>21</a:t>
+              <a:t>23</a:t>
             </a:fld>
             <a:endParaRPr lang="en-US"/>
           </a:p>
@@ -20879,7 +22531,7 @@
 </p:sld>
 </file>
 
-<file path=ppt/slides/slide22.xml><?xml version="1.0" encoding="utf-8"?>
+<file path=ppt/slides/slide24.xml><?xml version="1.0" encoding="utf-8"?>
 <p:sld xmlns:a="http://schemas.openxmlformats.org/drawingml/2006/main" xmlns:r="http://schemas.openxmlformats.org/officeDocument/2006/relationships" xmlns:p="http://schemas.openxmlformats.org/presentationml/2006/main">
   <p:cSld name="Slide 22">
     <p:spTree>
@@ -23325,7 +24977,7 @@
               <a:buNone/>
             </a:pPr>
             <a:r>
-              <a:rPr lang="en-US" sz="1300" dirty="0">
+              <a:rPr lang="es-MX" sz="1300">
                 <a:solidFill>
                   <a:srgbClr val="4A5568"/>
                 </a:solidFill>
@@ -23333,7 +24985,7 @@
                 <a:ea typeface="Calibri" pitchFamily="34" charset="-122"/>
                 <a:cs typeface="Calibri" pitchFamily="34" charset="-120"/>
               </a:rPr>
-              <a:t>casos ejecutados en este avance</a:t>
+              <a:t>casos ejecutados (se ejecutan en la Prueba de Conformidad)</a:t>
             </a:r>
             <a:endParaRPr lang="en-US" sz="1300" dirty="0"/>
           </a:p>
@@ -23381,7 +25033,7 @@
             <a:pPr algn="r"/>
             <a:fld id="{F7021451-1387-4CA6-816F-3879F97B5CBC}" type="slidenum">
               <a:rPr lang="en-US" b="0"/>
-              <a:t>22</a:t>
+              <a:t>24</a:t>
             </a:fld>
             <a:endParaRPr lang="en-US"/>
           </a:p>
@@ -23395,7 +25047,7 @@
 </p:sld>
 </file>
 
-<file path=ppt/slides/slide23.xml><?xml version="1.0" encoding="utf-8"?>
+<file path=ppt/slides/slide25.xml><?xml version="1.0" encoding="utf-8"?>
 <p:sld xmlns:a="http://schemas.openxmlformats.org/drawingml/2006/main" xmlns:r="http://schemas.openxmlformats.org/officeDocument/2006/relationships" xmlns:p="http://schemas.openxmlformats.org/presentationml/2006/main">
   <p:cSld name="Slide 23">
     <p:spTree>
@@ -29884,7 +31536,7 @@
         <p:spPr>
           <a:xfrm>
             <a:off x="457200" y="1463040"/>
-            <a:ext cx="1920240" cy="2377440"/>
+            <a:ext cx="1524000" cy="2377440"/>
           </a:xfrm>
           <a:prstGeom prst="roundRect">
             <a:avLst>
@@ -29917,8 +31569,8 @@
         </p:nvSpPr>
         <p:spPr>
           <a:xfrm>
-            <a:off x="594360" y="1737360"/>
-            <a:ext cx="1645920" cy="822960"/>
+            <a:off x="533400" y="1737360"/>
+            <a:ext cx="1371600" cy="822960"/>
           </a:xfrm>
           <a:prstGeom prst="rect">
             <a:avLst/>
@@ -29956,8 +31608,8 @@
         </p:nvSpPr>
         <p:spPr>
           <a:xfrm>
-            <a:off x="594360" y="2697480"/>
-            <a:ext cx="1645920" cy="914400"/>
+            <a:off x="533400" y="2697480"/>
+            <a:ext cx="1371600" cy="914400"/>
           </a:xfrm>
           <a:prstGeom prst="rect">
             <a:avLst/>
@@ -29995,8 +31647,8 @@
         </p:nvSpPr>
         <p:spPr>
           <a:xfrm>
-            <a:off x="2560320" y="1463040"/>
-            <a:ext cx="1920240" cy="2377440"/>
+            <a:off x="2133600" y="1463040"/>
+            <a:ext cx="1524000" cy="2377440"/>
           </a:xfrm>
           <a:prstGeom prst="roundRect">
             <a:avLst>
@@ -30029,8 +31681,8 @@
         </p:nvSpPr>
         <p:spPr>
           <a:xfrm>
-            <a:off x="2697480" y="1737360"/>
-            <a:ext cx="1645920" cy="822960"/>
+            <a:off x="2209800" y="1737360"/>
+            <a:ext cx="1371600" cy="822960"/>
           </a:xfrm>
           <a:prstGeom prst="rect">
             <a:avLst/>
@@ -30068,8 +31720,8 @@
         </p:nvSpPr>
         <p:spPr>
           <a:xfrm>
-            <a:off x="2697480" y="2697480"/>
-            <a:ext cx="1645920" cy="914400"/>
+            <a:off x="2209800" y="2697480"/>
+            <a:ext cx="1371600" cy="914400"/>
           </a:xfrm>
           <a:prstGeom prst="rect">
             <a:avLst/>
@@ -30107,8 +31759,8 @@
         </p:nvSpPr>
         <p:spPr>
           <a:xfrm>
-            <a:off x="4663440" y="1463040"/>
-            <a:ext cx="1920240" cy="2377440"/>
+            <a:off x="3810000" y="1463040"/>
+            <a:ext cx="1524000" cy="2377440"/>
           </a:xfrm>
           <a:prstGeom prst="roundRect">
             <a:avLst>
@@ -30141,8 +31793,8 @@
         </p:nvSpPr>
         <p:spPr>
           <a:xfrm>
-            <a:off x="4800600" y="1737360"/>
-            <a:ext cx="1645920" cy="822960"/>
+            <a:off x="3886200" y="1737360"/>
+            <a:ext cx="1371600" cy="822960"/>
           </a:xfrm>
           <a:prstGeom prst="rect">
             <a:avLst/>
@@ -30180,8 +31832,8 @@
         </p:nvSpPr>
         <p:spPr>
           <a:xfrm>
-            <a:off x="4800600" y="2697480"/>
-            <a:ext cx="1645920" cy="914400"/>
+            <a:off x="3886200" y="2697480"/>
+            <a:ext cx="1371600" cy="914400"/>
           </a:xfrm>
           <a:prstGeom prst="rect">
             <a:avLst/>
@@ -30219,8 +31871,8 @@
         </p:nvSpPr>
         <p:spPr>
           <a:xfrm>
-            <a:off x="6766560" y="1463040"/>
-            <a:ext cx="1920240" cy="2377440"/>
+            <a:off x="5486400" y="1463040"/>
+            <a:ext cx="1524000" cy="2377440"/>
           </a:xfrm>
           <a:prstGeom prst="roundRect">
             <a:avLst>
@@ -30253,8 +31905,8 @@
         </p:nvSpPr>
         <p:spPr>
           <a:xfrm>
-            <a:off x="6903720" y="1737360"/>
-            <a:ext cx="1645920" cy="822960"/>
+            <a:off x="5562600" y="1737360"/>
+            <a:ext cx="1371600" cy="822960"/>
           </a:xfrm>
           <a:prstGeom prst="rect">
             <a:avLst/>
@@ -30292,8 +31944,8 @@
         </p:nvSpPr>
         <p:spPr>
           <a:xfrm>
-            <a:off x="6903720" y="2697480"/>
-            <a:ext cx="1645920" cy="914400"/>
+            <a:off x="5562600" y="2697480"/>
+            <a:ext cx="1371600" cy="914400"/>
           </a:xfrm>
           <a:prstGeom prst="rect">
             <a:avLst/>
@@ -30368,6 +32020,136 @@
               <a:t>9</a:t>
             </a:fld>
             <a:endParaRPr lang="en-US"/>
+          </a:p>
+        </p:txBody>
+      </p:sp>
+      <p:sp>
+        <p:nvSpPr>
+          <p:cNvPr id="3" name="box163">
+            <a:extLst>
+              <a:ext uri="{FF2B5EF4-FFF2-40B4-BE49-F238E27FC236}">
+                <a16:creationId xmlns:a16="http://schemas.microsoft.com/office/drawing/2014/main" id="{FED9637A-F005-8524-06F5-751794117F49}"/>
+              </a:ext>
+            </a:extLst>
+          </p:cNvPr>
+          <p:cNvSpPr/>
+          <p:nvPr/>
+        </p:nvSpPr>
+        <p:spPr>
+          <a:xfrm>
+            <a:off x="7162800" y="1463040"/>
+            <a:ext cx="1524000" cy="2377440"/>
+          </a:xfrm>
+          <a:prstGeom prst="roundRect">
+            <a:avLst>
+              <a:gd name="adj" fmla="val 3810"/>
+            </a:avLst>
+          </a:prstGeom>
+          <a:solidFill>
+            <a:srgbClr val="EEF2F7"/>
+          </a:solidFill>
+          <a:ln w="12700">
+            <a:solidFill>
+              <a:srgbClr val="EEF2F7"/>
+            </a:solidFill>
+            <a:prstDash val="solid"/>
+          </a:ln>
+        </p:spPr>
+        <p:txBody>
+          <a:bodyPr/>
+          <a:lstStyle/>
+          <a:p>
+            <a:endParaRPr lang="es-PE"/>
+          </a:p>
+        </p:txBody>
+      </p:sp>
+      <p:sp>
+        <p:nvSpPr>
+          <p:cNvPr id="16" name="txt164">
+            <a:extLst>
+              <a:ext uri="{FF2B5EF4-FFF2-40B4-BE49-F238E27FC236}">
+                <a16:creationId xmlns:a16="http://schemas.microsoft.com/office/drawing/2014/main" id="{7A6A2A6E-B580-A351-FB74-DC2DC722390A}"/>
+              </a:ext>
+            </a:extLst>
+          </p:cNvPr>
+          <p:cNvSpPr txBox="1"/>
+          <p:nvPr/>
+        </p:nvSpPr>
+        <p:spPr>
+          <a:xfrm>
+            <a:off x="7239000" y="1737360"/>
+            <a:ext cx="1371600" cy="822960"/>
+          </a:xfrm>
+          <a:prstGeom prst="rect">
+            <a:avLst/>
+          </a:prstGeom>
+          <a:noFill/>
+          <a:ln/>
+        </p:spPr>
+        <p:txBody>
+          <a:bodyPr wrap="square" lIns="0" tIns="0" rIns="0" bIns="0" rtlCol="0" anchor="ctr"/>
+          <a:lstStyle/>
+          <a:p>
+            <a:pPr marL="0" indent="0" algn="ctr">
+              <a:buNone/>
+            </a:pPr>
+            <a:r>
+              <a:rPr lang="en-US" sz="3600" b="1">
+                <a:solidFill>
+                  <a:srgbClr val="14213D"/>
+                </a:solidFill>
+                <a:latin typeface="Calibri" pitchFamily="34" charset="0"/>
+                <a:ea typeface="Calibri" pitchFamily="34" charset="-122"/>
+                <a:cs typeface="Calibri" pitchFamily="34" charset="-120"/>
+              </a:rPr>
+              <a:t>≥ 80 %</a:t>
+            </a:r>
+            <a:endParaRPr lang="en-US" sz="3600" dirty="0"/>
+          </a:p>
+        </p:txBody>
+      </p:sp>
+      <p:sp>
+        <p:nvSpPr>
+          <p:cNvPr id="17" name="txt165">
+            <a:extLst>
+              <a:ext uri="{FF2B5EF4-FFF2-40B4-BE49-F238E27FC236}">
+                <a16:creationId xmlns:a16="http://schemas.microsoft.com/office/drawing/2014/main" id="{A18EED25-9394-B154-14B7-F6E8537B8BAD}"/>
+              </a:ext>
+            </a:extLst>
+          </p:cNvPr>
+          <p:cNvSpPr txBox="1"/>
+          <p:nvPr/>
+        </p:nvSpPr>
+        <p:spPr>
+          <a:xfrm>
+            <a:off x="7239000" y="2697480"/>
+            <a:ext cx="1371600" cy="914400"/>
+          </a:xfrm>
+          <a:prstGeom prst="rect">
+            <a:avLst/>
+          </a:prstGeom>
+          <a:noFill/>
+          <a:ln/>
+        </p:spPr>
+        <p:txBody>
+          <a:bodyPr wrap="square" lIns="0" tIns="0" rIns="0" bIns="0" rtlCol="0" anchor="t"/>
+          <a:lstStyle/>
+          <a:p>
+            <a:pPr marL="0" indent="0" algn="ctr">
+              <a:buNone/>
+            </a:pPr>
+            <a:r>
+              <a:rPr lang="es-MX" sz="1400">
+                <a:solidFill>
+                  <a:srgbClr val="4A5568"/>
+                </a:solidFill>
+                <a:latin typeface="Calibri" pitchFamily="34" charset="0"/>
+                <a:ea typeface="Calibri" pitchFamily="34" charset="-122"/>
+                <a:cs typeface="Calibri" pitchFamily="34" charset="-120"/>
+              </a:rPr>
+              <a:t>de éxito en UAT (Maze) y SUS ≥ 68</a:t>
+            </a:r>
+            <a:endParaRPr lang="en-US" sz="1400" dirty="0"/>
           </a:p>
         </p:txBody>
       </p:sp>

</xml_diff>

<commit_message>
Carátula UTP en los documentos y presentación resumida de los tres planes
- Carátula de docs/caratula.docx aplicada a los 5 documentos Word (título adaptado).
- Portada de la presentación del esquema con logo y datos del curso.
- Nueva presentación de 20 diapositivas: Plan de Pruebas, Plan de Calidad
  y Prueba de Conformidad, con notas del orador.

Co-Authored-By: Claude Opus 5.5 <noreply@anthropic.com>
</commit_message>
<xml_diff>
--- a/docs/Esquema_Calidad_Pruebas_Conformidad.pptx
+++ b/docs/Esquema_Calidad_Pruebas_Conformidad.pptx
@@ -2643,7 +2643,7 @@
           </a:prstGeom>
           <a:extLst>
             <a:ext uri="{C572A759-6A51-4108-AA02-DFA0A04FC94B}">
-              <ma14:wrappingTextBoxFlag xmlns:ma14="http://schemas.microsoft.com/office/mac/drawingml/2011/main" xmlns="" val="0"/>
+              <ma14:wrappingTextBoxFlag xmlns="" xmlns:ma14="http://schemas.microsoft.com/office/mac/drawingml/2011/main" val="0"/>
             </a:ext>
           </a:extLst>
         </p:spPr>
@@ -2798,7 +2798,7 @@
           </a:prstGeom>
           <a:extLst>
             <a:ext uri="{C572A759-6A51-4108-AA02-DFA0A04FC94B}">
-              <ma14:wrappingTextBoxFlag xmlns:ma14="http://schemas.microsoft.com/office/mac/drawingml/2011/main" xmlns="" val="0"/>
+              <ma14:wrappingTextBoxFlag xmlns="" xmlns:ma14="http://schemas.microsoft.com/office/mac/drawingml/2011/main" val="0"/>
             </a:ext>
           </a:extLst>
         </p:spPr>
@@ -3130,7 +3130,7 @@
               <a:buNone/>
             </a:pPr>
             <a:r>
-              <a:rPr lang="en-US" sz="1400" b="1" kern="0" spc="200">
+              <a:rPr lang="es-MX" sz="1400" b="1" kern="0" spc="200">
                 <a:solidFill>
                   <a:srgbClr val="FCA311"/>
                 </a:solidFill>
@@ -3138,7 +3138,7 @@
                 <a:ea typeface="Calibri" pitchFamily="34" charset="-122"/>
                 <a:cs typeface="Calibri" pitchFamily="34" charset="-120"/>
               </a:rPr>
-              <a:t>CALIDAD DE SOFTWARE</a:t>
+              <a:t>FACULTAD DE INGENIERÍA · INGENIERÍA DE SOFTWARE</a:t>
             </a:r>
             <a:endParaRPr lang="en-US" sz="1400" dirty="0"/>
           </a:p>
@@ -3211,7 +3211,7 @@
               <a:buNone/>
             </a:pPr>
             <a:r>
-              <a:rPr lang="en-US" sz="1400" b="1" dirty="0">
+              <a:rPr lang="en-US" sz="1400" b="1">
                 <a:solidFill>
                   <a:srgbClr val="FCA311"/>
                 </a:solidFill>
@@ -3219,20 +3219,19 @@
                 <a:ea typeface="Calibri" pitchFamily="34" charset="-122"/>
                 <a:cs typeface="Calibri" pitchFamily="34" charset="-120"/>
               </a:rPr>
-              <a:t>Estudiante: </a:t>
-            </a:r>
-            <a:r>
-              <a:rPr lang="en-US" sz="1400" dirty="0">
-                <a:solidFill>
-                  <a:srgbClr val="FFFFFF"/>
+              <a:t>Curso: </a:t>
+            </a:r>
+            <a:r>
+              <a:rPr lang="en-US" sz="1400">
+                <a:solidFill>
+                  <a:srgbClr val="C9D3E3"/>
                 </a:solidFill>
                 <a:latin typeface="Calibri" pitchFamily="34" charset="0"/>
                 <a:ea typeface="Calibri" pitchFamily="34" charset="-122"/>
                 <a:cs typeface="Calibri" pitchFamily="34" charset="-120"/>
               </a:rPr>
-              <a:t>Diego Aarón Damián Valdivia</a:t>
-            </a:r>
-            <a:endParaRPr lang="en-US" sz="1400" dirty="0"/>
+              <a:t>Calidad de Software – Sección 37648</a:t>
+            </a:r>
           </a:p>
           <a:p>
             <a:pPr marL="0" indent="0">
@@ -3242,7 +3241,7 @@
               <a:buNone/>
             </a:pPr>
             <a:r>
-              <a:rPr lang="en-US" sz="1400" b="1" dirty="0">
+              <a:rPr lang="en-US" sz="1400" b="1">
                 <a:solidFill>
                   <a:srgbClr val="FCA311"/>
                 </a:solidFill>
@@ -3250,20 +3249,19 @@
                 <a:ea typeface="Calibri" pitchFamily="34" charset="-122"/>
                 <a:cs typeface="Calibri" pitchFamily="34" charset="-120"/>
               </a:rPr>
-              <a:t>Docente: </a:t>
-            </a:r>
-            <a:r>
-              <a:rPr lang="en-US" sz="1400" dirty="0">
-                <a:solidFill>
-                  <a:srgbClr val="FFFFFF"/>
+              <a:t>Profesor: </a:t>
+            </a:r>
+            <a:r>
+              <a:rPr lang="en-US" sz="1400">
+                <a:solidFill>
+                  <a:srgbClr val="C9D3E3"/>
                 </a:solidFill>
                 <a:latin typeface="Calibri" pitchFamily="34" charset="0"/>
                 <a:ea typeface="Calibri" pitchFamily="34" charset="-122"/>
                 <a:cs typeface="Calibri" pitchFamily="34" charset="-120"/>
               </a:rPr>
-              <a:t>Jorge Luis Blanco Reyna</a:t>
-            </a:r>
-            <a:endParaRPr lang="en-US" sz="1400" dirty="0"/>
+              <a:t>Ing. Jorge Luis Blanco Reyna</a:t>
+            </a:r>
           </a:p>
           <a:p>
             <a:pPr marL="0" indent="0">
@@ -3273,15 +3271,15 @@
               <a:buNone/>
             </a:pPr>
             <a:r>
-              <a:rPr lang="en-US" sz="1400" dirty="0">
-                <a:solidFill>
-                  <a:srgbClr val="C9D3E3"/>
+              <a:rPr lang="en-US" sz="1400" b="1">
+                <a:solidFill>
+                  <a:srgbClr val="FCA311"/>
                 </a:solidFill>
                 <a:latin typeface="Calibri" pitchFamily="34" charset="0"/>
                 <a:ea typeface="Calibri" pitchFamily="34" charset="-122"/>
                 <a:cs typeface="Calibri" pitchFamily="34" charset="-120"/>
               </a:rPr>
-              <a:t>Octubre de 2026 </a:t>
+              <a:t>Integrantes: </a:t>
             </a:r>
             <a:r>
               <a:rPr lang="en-US" sz="1400">
@@ -3292,12 +3290,135 @@
                 <a:ea typeface="Calibri" pitchFamily="34" charset="-122"/>
                 <a:cs typeface="Calibri" pitchFamily="34" charset="-120"/>
               </a:rPr>
-              <a:t>· Versión 1.0</a:t>
-            </a:r>
-            <a:endParaRPr lang="en-US" sz="1400" dirty="0"/>
-          </a:p>
-        </p:txBody>
-      </p:sp>
+              <a:t>DAMIÁN VALDIVIA, Diego Aarón</a:t>
+            </a:r>
+          </a:p>
+          <a:p>
+            <a:pPr marL="0" indent="0">
+              <a:spcAft>
+                <a:spcPts val="400"/>
+              </a:spcAft>
+              <a:buNone/>
+            </a:pPr>
+            <a:r>
+              <a:rPr lang="en-US" sz="1400">
+                <a:solidFill>
+                  <a:srgbClr val="C9D3E3"/>
+                </a:solidFill>
+                <a:latin typeface="Calibri" pitchFamily="34" charset="0"/>
+                <a:ea typeface="Calibri" pitchFamily="34" charset="-122"/>
+                <a:cs typeface="Calibri" pitchFamily="34" charset="-120"/>
+              </a:rPr>
+              <a:t>Lima – Perú, 2026 · Versión 1.0</a:t>
+            </a:r>
+            <a:endParaRPr lang="en-US" sz="1400" dirty="0">
+              <a:solidFill>
+                <a:srgbClr val="C9D3E3"/>
+              </a:solidFill>
+            </a:endParaRPr>
+          </a:p>
+        </p:txBody>
+      </p:sp>
+      <p:sp>
+        <p:nvSpPr>
+          <p:cNvPr id="4" name="logoCard">
+            <a:extLst>
+              <a:ext uri="{FF2B5EF4-FFF2-40B4-BE49-F238E27FC236}">
+                <a16:creationId xmlns:a16="http://schemas.microsoft.com/office/drawing/2014/main" id="{C0158DFF-2233-748E-6FB7-4A16D6664521}"/>
+              </a:ext>
+            </a:extLst>
+          </p:cNvPr>
+          <p:cNvSpPr/>
+          <p:nvPr/>
+        </p:nvSpPr>
+        <p:spPr>
+          <a:xfrm>
+            <a:off x="6604000" y="508000"/>
+            <a:ext cx="1905000" cy="635000"/>
+          </a:xfrm>
+          <a:prstGeom prst="roundRect">
+            <a:avLst>
+              <a:gd name="adj" fmla="val 12000"/>
+            </a:avLst>
+          </a:prstGeom>
+          <a:solidFill>
+            <a:srgbClr val="FFFFFF"/>
+          </a:solidFill>
+          <a:ln w="12700" cap="flat" cmpd="sng" algn="ctr">
+            <a:noFill/>
+            <a:prstDash val="solid"/>
+            <a:miter lim="800000"/>
+          </a:ln>
+          <a:effectLst/>
+          <a:extLst>
+            <a:ext uri="{91240B29-F687-4F45-9708-019B960494DF}">
+              <a14:hiddenLine xmlns:a14="http://schemas.microsoft.com/office/drawing/2010/main" w="12700" cap="flat" cmpd="sng" algn="ctr">
+                <a:solidFill>
+                  <a:schemeClr val="accent1">
+                    <a:shade val="15000"/>
+                  </a:schemeClr>
+                </a:solidFill>
+                <a:prstDash val="solid"/>
+                <a:miter lim="800000"/>
+              </a14:hiddenLine>
+            </a:ext>
+          </a:extLst>
+        </p:spPr>
+        <p:style>
+          <a:lnRef idx="2">
+            <a:schemeClr val="accent1">
+              <a:shade val="15000"/>
+            </a:schemeClr>
+          </a:lnRef>
+          <a:fillRef idx="1">
+            <a:schemeClr val="accent1"/>
+          </a:fillRef>
+          <a:effectRef idx="0">
+            <a:schemeClr val="accent1"/>
+          </a:effectRef>
+          <a:fontRef idx="minor">
+            <a:schemeClr val="lt1"/>
+          </a:fontRef>
+        </p:style>
+        <p:txBody>
+          <a:bodyPr rtlCol="0" anchor="ctr"/>
+          <a:lstStyle/>
+          <a:p>
+            <a:pPr algn="ctr"/>
+            <a:endParaRPr lang="es-PE"/>
+          </a:p>
+        </p:txBody>
+      </p:sp>
+      <p:pic>
+        <p:nvPicPr>
+          <p:cNvPr id="7" name="logoUTP" descr="Logo de la Universidad Tecnológica del Perú">
+            <a:extLst>
+              <a:ext uri="{FF2B5EF4-FFF2-40B4-BE49-F238E27FC236}">
+                <a16:creationId xmlns:a16="http://schemas.microsoft.com/office/drawing/2014/main" id="{585C0159-974E-7851-B736-BB0F8F2956DA}"/>
+              </a:ext>
+            </a:extLst>
+          </p:cNvPr>
+          <p:cNvPicPr>
+            <a:picLocks/>
+          </p:cNvPicPr>
+          <p:nvPr/>
+        </p:nvPicPr>
+        <p:blipFill>
+          <a:blip r:embed="rId3"/>
+          <a:stretch>
+            <a:fillRect/>
+          </a:stretch>
+        </p:blipFill>
+        <p:spPr>
+          <a:xfrm>
+            <a:off x="6731000" y="590550"/>
+            <a:ext cx="1651000" cy="439420"/>
+          </a:xfrm>
+          <a:prstGeom prst="rect">
+            <a:avLst/>
+          </a:prstGeom>
+        </p:spPr>
+      </p:pic>
     </p:spTree>
   </p:cSld>
   <p:clrMapOvr>
@@ -4728,7 +4849,7 @@
           </a:prstGeom>
           <a:extLst>
             <a:ext uri="{C572A759-6A51-4108-AA02-DFA0A04FC94B}">
-              <ma14:wrappingTextBoxFlag xmlns:ma14="http://schemas.microsoft.com/office/mac/drawingml/2011/main" xmlns="" val="0"/>
+              <ma14:wrappingTextBoxFlag xmlns="" xmlns:ma14="http://schemas.microsoft.com/office/mac/drawingml/2011/main" val="0"/>
             </a:ext>
           </a:extLst>
         </p:spPr>
@@ -7690,7 +7811,7 @@
           </a:prstGeom>
           <a:extLst>
             <a:ext uri="{C572A759-6A51-4108-AA02-DFA0A04FC94B}">
-              <ma14:wrappingTextBoxFlag xmlns:ma14="http://schemas.microsoft.com/office/mac/drawingml/2011/main" xmlns="" val="0"/>
+              <ma14:wrappingTextBoxFlag xmlns="" xmlns:ma14="http://schemas.microsoft.com/office/mac/drawingml/2011/main" val="0"/>
             </a:ext>
           </a:extLst>
         </p:spPr>
@@ -8514,7 +8635,7 @@
           </a:prstGeom>
           <a:extLst>
             <a:ext uri="{C572A759-6A51-4108-AA02-DFA0A04FC94B}">
-              <ma14:wrappingTextBoxFlag xmlns:ma14="http://schemas.microsoft.com/office/mac/drawingml/2011/main" xmlns="" val="0"/>
+              <ma14:wrappingTextBoxFlag xmlns="" xmlns:ma14="http://schemas.microsoft.com/office/mac/drawingml/2011/main" val="0"/>
             </a:ext>
           </a:extLst>
         </p:spPr>
@@ -10678,7 +10799,7 @@
           </a:prstGeom>
           <a:extLst>
             <a:ext uri="{C572A759-6A51-4108-AA02-DFA0A04FC94B}">
-              <ma14:wrappingTextBoxFlag xmlns:ma14="http://schemas.microsoft.com/office/mac/drawingml/2011/main" xmlns="" val="0"/>
+              <ma14:wrappingTextBoxFlag xmlns="" xmlns:ma14="http://schemas.microsoft.com/office/mac/drawingml/2011/main" val="0"/>
             </a:ext>
           </a:extLst>
         </p:spPr>
@@ -12842,7 +12963,7 @@
           </a:prstGeom>
           <a:extLst>
             <a:ext uri="{C572A759-6A51-4108-AA02-DFA0A04FC94B}">
-              <ma14:wrappingTextBoxFlag xmlns:ma14="http://schemas.microsoft.com/office/mac/drawingml/2011/main" xmlns="" val="0"/>
+              <ma14:wrappingTextBoxFlag xmlns="" xmlns:ma14="http://schemas.microsoft.com/office/mac/drawingml/2011/main" val="0"/>
             </a:ext>
           </a:extLst>
         </p:spPr>
@@ -13720,7 +13841,7 @@
           </a:prstGeom>
           <a:extLst>
             <a:ext uri="{C572A759-6A51-4108-AA02-DFA0A04FC94B}">
-              <ma14:wrappingTextBoxFlag xmlns="" xmlns:ma14="http://schemas.microsoft.com/office/mac/drawingml/2011/main" val="0"/>
+              <ma14:wrappingTextBoxFlag xmlns:ma14="http://schemas.microsoft.com/office/mac/drawingml/2011/main" xmlns="" val="0"/>
             </a:ext>
           </a:extLst>
         </p:spPr>
@@ -15064,7 +15185,7 @@
           </a:prstGeom>
           <a:extLst>
             <a:ext uri="{C572A759-6A51-4108-AA02-DFA0A04FC94B}">
-              <ma14:wrappingTextBoxFlag xmlns:ma14="http://schemas.microsoft.com/office/mac/drawingml/2011/main" xmlns="" val="0"/>
+              <ma14:wrappingTextBoxFlag xmlns="" xmlns:ma14="http://schemas.microsoft.com/office/mac/drawingml/2011/main" val="0"/>
             </a:ext>
           </a:extLst>
         </p:spPr>
@@ -15892,7 +16013,7 @@
           </a:prstGeom>
           <a:extLst>
             <a:ext uri="{C572A759-6A51-4108-AA02-DFA0A04FC94B}">
-              <ma14:wrappingTextBoxFlag xmlns:ma14="http://schemas.microsoft.com/office/mac/drawingml/2011/main" xmlns="" val="0"/>
+              <ma14:wrappingTextBoxFlag xmlns="" xmlns:ma14="http://schemas.microsoft.com/office/mac/drawingml/2011/main" val="0"/>
             </a:ext>
           </a:extLst>
         </p:spPr>
@@ -16456,7 +16577,7 @@
           </a:prstGeom>
           <a:extLst>
             <a:ext uri="{C572A759-6A51-4108-AA02-DFA0A04FC94B}">
-              <ma14:wrappingTextBoxFlag xmlns="" xmlns:ma14="http://schemas.microsoft.com/office/mac/drawingml/2011/main" val="0"/>
+              <ma14:wrappingTextBoxFlag xmlns:ma14="http://schemas.microsoft.com/office/mac/drawingml/2011/main" xmlns="" val="0"/>
             </a:ext>
           </a:extLst>
         </p:spPr>
@@ -17210,7 +17331,7 @@
           </a:prstGeom>
           <a:extLst>
             <a:ext uri="{C572A759-6A51-4108-AA02-DFA0A04FC94B}">
-              <ma14:wrappingTextBoxFlag xmlns:ma14="http://schemas.microsoft.com/office/mac/drawingml/2011/main" xmlns="" val="0"/>
+              <ma14:wrappingTextBoxFlag xmlns="" xmlns:ma14="http://schemas.microsoft.com/office/mac/drawingml/2011/main" val="0"/>
             </a:ext>
           </a:extLst>
         </p:spPr>
@@ -19513,7 +19634,7 @@
           </a:prstGeom>
           <a:extLst>
             <a:ext uri="{C572A759-6A51-4108-AA02-DFA0A04FC94B}">
-              <ma14:wrappingTextBoxFlag xmlns:ma14="http://schemas.microsoft.com/office/mac/drawingml/2011/main" xmlns="" val="0"/>
+              <ma14:wrappingTextBoxFlag xmlns="" xmlns:ma14="http://schemas.microsoft.com/office/mac/drawingml/2011/main" val="0"/>
             </a:ext>
           </a:extLst>
         </p:spPr>
@@ -20959,7 +21080,7 @@
           </a:prstGeom>
           <a:extLst>
             <a:ext uri="{C572A759-6A51-4108-AA02-DFA0A04FC94B}">
-              <ma14:wrappingTextBoxFlag xmlns:ma14="http://schemas.microsoft.com/office/mac/drawingml/2011/main" xmlns="" val="0"/>
+              <ma14:wrappingTextBoxFlag xmlns="" xmlns:ma14="http://schemas.microsoft.com/office/mac/drawingml/2011/main" val="0"/>
             </a:ext>
           </a:extLst>
         </p:spPr>
@@ -22495,7 +22616,7 @@
           </a:prstGeom>
           <a:extLst>
             <a:ext uri="{C572A759-6A51-4108-AA02-DFA0A04FC94B}">
-              <ma14:wrappingTextBoxFlag xmlns:ma14="http://schemas.microsoft.com/office/mac/drawingml/2011/main" xmlns="" val="0"/>
+              <ma14:wrappingTextBoxFlag xmlns="" xmlns:ma14="http://schemas.microsoft.com/office/mac/drawingml/2011/main" val="0"/>
             </a:ext>
           </a:extLst>
         </p:spPr>
@@ -25011,7 +25132,7 @@
           </a:prstGeom>
           <a:extLst>
             <a:ext uri="{C572A759-6A51-4108-AA02-DFA0A04FC94B}">
-              <ma14:wrappingTextBoxFlag xmlns:ma14="http://schemas.microsoft.com/office/mac/drawingml/2011/main" xmlns="" val="0"/>
+              <ma14:wrappingTextBoxFlag xmlns="" xmlns:ma14="http://schemas.microsoft.com/office/mac/drawingml/2011/main" val="0"/>
             </a:ext>
           </a:extLst>
         </p:spPr>
@@ -26368,7 +26489,7 @@
           </a:prstGeom>
           <a:extLst>
             <a:ext uri="{C572A759-6A51-4108-AA02-DFA0A04FC94B}">
-              <ma14:wrappingTextBoxFlag xmlns:ma14="http://schemas.microsoft.com/office/mac/drawingml/2011/main" xmlns="" val="0"/>
+              <ma14:wrappingTextBoxFlag xmlns="" xmlns:ma14="http://schemas.microsoft.com/office/mac/drawingml/2011/main" val="0"/>
             </a:ext>
           </a:extLst>
         </p:spPr>
@@ -27412,7 +27533,7 @@
           </a:prstGeom>
           <a:extLst>
             <a:ext uri="{C572A759-6A51-4108-AA02-DFA0A04FC94B}">
-              <ma14:wrappingTextBoxFlag xmlns:ma14="http://schemas.microsoft.com/office/mac/drawingml/2011/main" xmlns="" val="0"/>
+              <ma14:wrappingTextBoxFlag xmlns="" xmlns:ma14="http://schemas.microsoft.com/office/mac/drawingml/2011/main" val="0"/>
             </a:ext>
           </a:extLst>
         </p:spPr>
@@ -28239,7 +28360,7 @@
           </a:prstGeom>
           <a:extLst>
             <a:ext uri="{C572A759-6A51-4108-AA02-DFA0A04FC94B}">
-              <ma14:wrappingTextBoxFlag xmlns:ma14="http://schemas.microsoft.com/office/mac/drawingml/2011/main" xmlns="" val="0"/>
+              <ma14:wrappingTextBoxFlag xmlns="" xmlns:ma14="http://schemas.microsoft.com/office/mac/drawingml/2011/main" val="0"/>
             </a:ext>
           </a:extLst>
         </p:spPr>
@@ -30469,7 +30590,7 @@
           </a:prstGeom>
           <a:extLst>
             <a:ext uri="{C572A759-6A51-4108-AA02-DFA0A04FC94B}">
-              <ma14:wrappingTextBoxFlag xmlns:ma14="http://schemas.microsoft.com/office/mac/drawingml/2011/main" xmlns="" val="0"/>
+              <ma14:wrappingTextBoxFlag xmlns="" xmlns:ma14="http://schemas.microsoft.com/office/mac/drawingml/2011/main" val="0"/>
             </a:ext>
           </a:extLst>
         </p:spPr>
@@ -31431,7 +31552,7 @@
           </a:prstGeom>
           <a:extLst>
             <a:ext uri="{C572A759-6A51-4108-AA02-DFA0A04FC94B}">
-              <ma14:wrappingTextBoxFlag xmlns:ma14="http://schemas.microsoft.com/office/mac/drawingml/2011/main" xmlns="" val="0"/>
+              <ma14:wrappingTextBoxFlag xmlns="" xmlns:ma14="http://schemas.microsoft.com/office/mac/drawingml/2011/main" val="0"/>
             </a:ext>
           </a:extLst>
         </p:spPr>
@@ -31995,7 +32116,7 @@
           </a:prstGeom>
           <a:extLst>
             <a:ext uri="{C572A759-6A51-4108-AA02-DFA0A04FC94B}">
-              <ma14:wrappingTextBoxFlag xmlns:ma14="http://schemas.microsoft.com/office/mac/drawingml/2011/main" xmlns="" val="0"/>
+              <ma14:wrappingTextBoxFlag xmlns="" xmlns:ma14="http://schemas.microsoft.com/office/mac/drawingml/2011/main" val="0"/>
             </a:ext>
           </a:extLst>
         </p:spPr>

</xml_diff>

<commit_message>
Herramienta propia de usabilidad en lugar de Maze en los documentos
- Esquema, Plan de Pruebas, Plan de Calidad, Informe de HU y presentación
  del esquema: las menciones a Maze pasan a la herramienta propia
  (usabilidad.html).
- Nuevo documento de análisis de requerimientos, HU y resumen de planes.
- Presentación ampliada a 35 diapositivas.
- referencias/ excluida de git.
</commit_message>
<xml_diff>
--- a/docs/Esquema_Calidad_Pruebas_Conformidad.pptx
+++ b/docs/Esquema_Calidad_Pruebas_Conformidad.pptx
@@ -2270,7 +2270,7 @@
           <a:p>
             <a:r>
               <a:rPr lang="en-US" dirty="0"/>
-              <a:t>Cada tarjeta es una métrica con su meta mínima. Por ejemplo, la fiabilidad se mide con las 53 pruebas unitarias, que deben pasar al 100 %, y la usabilidad con la tasa de éxito en Maze y la escala SUS.</a:t>
+              <a:t>Cada tarjeta es una métrica con su meta mínima. Por ejemplo, la fiabilidad se mide con las 53 pruebas unitarias, que deben pasar al 100 %, y la usabilidad con la tasa de éxito con la herramienta propia y la escala SUS.</a:t>
             </a:r>
           </a:p>
         </p:txBody>
@@ -2357,7 +2357,7 @@
           <a:p>
             <a:r>
               <a:rPr lang="en-US" dirty="0"/>
-              <a:t>Las estrategias se apoyan en herramientas gratuitas y sin backend: el mini-framework de pruebas en el navegador, DevTools y Lighthouse, Maze y GitHub.</a:t>
+              <a:t>Las estrategias se apoyan en herramientas gratuitas y sin backend: el mini-framework de pruebas en el navegador, DevTools y Lighthouse, la herramienta propia de usabilidad y GitHub.</a:t>
             </a:r>
           </a:p>
         </p:txBody>
@@ -4643,7 +4643,7 @@
                 <a:ea typeface="Calibri" pitchFamily="34" charset="-122"/>
                 <a:cs typeface="Calibri" pitchFamily="34" charset="-120"/>
               </a:rPr>
-              <a:t>Maze + checklist · Usuarios clave</a:t>
+              <a:t>Herramienta propia + checklist · Usuarios clave</a:t>
             </a:r>
             <a:endParaRPr lang="en-US" sz="1000" dirty="0"/>
           </a:p>
@@ -6267,7 +6267,7 @@
                           <a:ea typeface="Calibri" pitchFamily="34" charset="-122"/>
                           <a:cs typeface="Calibri" pitchFamily="34" charset="-120"/>
                         </a:rPr>
-                        <a:t>Maze: tareas + SUS</a:t>
+                        <a:t>Herramienta propia: tareas + SUS</a:t>
                       </a:r>
                       <a:endParaRPr lang="en-US" sz="1200" dirty="0">
                         <a:latin typeface="Calibri" charset="0"/>
@@ -13300,7 +13300,7 @@
                 <a:ea typeface="Calibri" pitchFamily="34" charset="-122"/>
                 <a:cs typeface="Calibri" pitchFamily="34" charset="-120"/>
               </a:rPr>
-              <a:t>Usuarios clave: UAT en Maze</a:t>
+              <a:t>Usuarios clave: UAT con la herramienta propia</a:t>
             </a:r>
             <a:endParaRPr lang="en-US" sz="1400" dirty="0"/>
           </a:p>
@@ -13547,7 +13547,7 @@
                 <a:ea typeface="Calibri" pitchFamily="34" charset="-122"/>
                 <a:cs typeface="Calibri" pitchFamily="34" charset="-120"/>
               </a:rPr>
-              <a:t>tests.html, DevTools, Lighthouse, Maze, GitHub Issues</a:t>
+              <a:t>tests.html, DevTools, Lighthouse, usabilidad.html, GitHub Issues</a:t>
             </a:r>
             <a:endParaRPr lang="en-US" sz="1400" dirty="0"/>
           </a:p>
@@ -14523,7 +14523,7 @@
                 <a:ea typeface="Calibri" pitchFamily="34" charset="-122"/>
                 <a:cs typeface="Calibri" pitchFamily="34" charset="-120"/>
               </a:rPr>
-              <a:t>Usabilidad Maze (UAT)</a:t>
+              <a:t>Usabilidad propia (UAT)</a:t>
             </a:r>
             <a:endParaRPr lang="en-US" sz="1300" dirty="0"/>
           </a:p>
@@ -15526,7 +15526,7 @@
                 <a:ea typeface="Calibri" pitchFamily="34" charset="-122"/>
                 <a:cs typeface="Calibri" pitchFamily="34" charset="-120"/>
               </a:rPr>
-              <a:t>Pocos participantes para Maze</a:t>
+              <a:t>Pocos participantes para la prueba de usabilidad</a:t>
             </a:r>
             <a:endParaRPr lang="en-US" sz="1400" dirty="0"/>
           </a:p>
@@ -16439,7 +16439,7 @@
                 <a:ea typeface="Calibri" pitchFamily="34" charset="-122"/>
                 <a:cs typeface="Calibri" pitchFamily="34" charset="-120"/>
               </a:rPr>
-              <a:t>de éxito en UAT (Maze) y SUS ≥ 68</a:t>
+              <a:t>de éxito en UAT (herramienta propia) y SUS ≥ 68</a:t>
             </a:r>
             <a:endParaRPr lang="en-US" sz="1400" dirty="0"/>
           </a:p>
@@ -25548,7 +25548,7 @@
                 <a:ea typeface="Calibri" pitchFamily="34" charset="-122"/>
                 <a:cs typeface="Calibri" pitchFamily="34" charset="-120"/>
               </a:rPr>
-              <a:t>Completar la prueba de usabilidad en Maze</a:t>
+              <a:t>Completar la prueba de usabilidad con la herramienta propia</a:t>
             </a:r>
             <a:endParaRPr lang="en-US" sz="1700" dirty="0"/>
           </a:p>
@@ -29658,7 +29658,7 @@
                 <a:ea typeface="Calibri" pitchFamily="34" charset="-122"/>
                 <a:cs typeface="Calibri" pitchFamily="34" charset="-120"/>
               </a:rPr>
-              <a:t>Tasa de éxito en Maze</a:t>
+              <a:t>Tasa de éxito con la herramienta propia</a:t>
             </a:r>
             <a:endParaRPr lang="en-US" sz="1000" dirty="0"/>
           </a:p>
@@ -31464,7 +31464,7 @@
                 <a:ea typeface="Calibri" pitchFamily="34" charset="-122"/>
                 <a:cs typeface="Calibri" pitchFamily="34" charset="-120"/>
               </a:rPr>
-              <a:t>Maze</a:t>
+              <a:t>herramienta propia</a:t>
             </a:r>
             <a:endParaRPr lang="en-US" sz="1300" dirty="0"/>
           </a:p>
@@ -32268,7 +32268,7 @@
                 <a:ea typeface="Calibri" pitchFamily="34" charset="-122"/>
                 <a:cs typeface="Calibri" pitchFamily="34" charset="-120"/>
               </a:rPr>
-              <a:t>de éxito en UAT (Maze) y SUS ≥ 68</a:t>
+              <a:t>de éxito en UAT (herramienta propia) y SUS ≥ 68</a:t>
             </a:r>
             <a:endParaRPr lang="en-US" sz="1400" dirty="0"/>
           </a:p>

</xml_diff>